<commit_message>
add my template slide
</commit_message>
<xml_diff>
--- a/Auth/RESTなHTTP通信とsessionについて.pptx
+++ b/Auth/RESTなHTTP通信とsessionについて.pptx
@@ -5,7 +5,7 @@
     <p:sldMasterId id="2147483648" r:id="rId1"/>
   </p:sldMasterIdLst>
   <p:notesMasterIdLst>
-    <p:notesMasterId r:id="rId15"/>
+    <p:notesMasterId r:id="rId14"/>
   </p:notesMasterIdLst>
   <p:sldIdLst>
     <p:sldId id="256" r:id="rId2"/>
@@ -16,11 +16,10 @@
     <p:sldId id="275" r:id="rId7"/>
     <p:sldId id="290" r:id="rId8"/>
     <p:sldId id="291" r:id="rId9"/>
-    <p:sldId id="292" r:id="rId10"/>
-    <p:sldId id="293" r:id="rId11"/>
-    <p:sldId id="268" r:id="rId12"/>
-    <p:sldId id="269" r:id="rId13"/>
-    <p:sldId id="264" r:id="rId14"/>
+    <p:sldId id="293" r:id="rId10"/>
+    <p:sldId id="268" r:id="rId11"/>
+    <p:sldId id="269" r:id="rId12"/>
+    <p:sldId id="264" r:id="rId13"/>
   </p:sldIdLst>
   <p:sldSz cx="12192000" cy="6858000"/>
   <p:notesSz cx="6858000" cy="9144000"/>
@@ -140,7 +139,6 @@
             <p14:sldId id="275"/>
             <p14:sldId id="290"/>
             <p14:sldId id="291"/>
-            <p14:sldId id="292"/>
             <p14:sldId id="293"/>
             <p14:sldId id="268"/>
             <p14:sldId id="269"/>
@@ -5512,1617 +5510,6 @@
         <p:cNvPr id="1" name="">
           <a:extLst>
             <a:ext uri="{FF2B5EF4-FFF2-40B4-BE49-F238E27FC236}">
-              <a16:creationId xmlns:a16="http://schemas.microsoft.com/office/drawing/2014/main" id="{F4C1BDB2-5649-A327-2B01-93BF748FEFD9}"/>
-            </a:ext>
-          </a:extLst>
-        </p:cNvPr>
-        <p:cNvGrpSpPr/>
-        <p:nvPr/>
-      </p:nvGrpSpPr>
-      <p:grpSpPr>
-        <a:xfrm>
-          <a:off x="0" y="0"/>
-          <a:ext cx="0" cy="0"/>
-          <a:chOff x="0" y="0"/>
-          <a:chExt cx="0" cy="0"/>
-        </a:xfrm>
-      </p:grpSpPr>
-      <p:cxnSp>
-        <p:nvCxnSpPr>
-          <p:cNvPr id="2" name="直線コネクタ 1">
-            <a:extLst>
-              <a:ext uri="{FF2B5EF4-FFF2-40B4-BE49-F238E27FC236}">
-                <a16:creationId xmlns:a16="http://schemas.microsoft.com/office/drawing/2014/main" id="{A1B8D59F-005F-C25E-624C-282771D1CBF8}"/>
-              </a:ext>
-            </a:extLst>
-          </p:cNvPr>
-          <p:cNvCxnSpPr>
-            <a:cxnSpLocks/>
-          </p:cNvCxnSpPr>
-          <p:nvPr/>
-        </p:nvCxnSpPr>
-        <p:spPr>
-          <a:xfrm>
-            <a:off x="0" y="1993900"/>
-            <a:ext cx="12192000" cy="0"/>
-          </a:xfrm>
-          <a:prstGeom prst="line">
-            <a:avLst/>
-          </a:prstGeom>
-          <a:ln w="38100"/>
-        </p:spPr>
-        <p:style>
-          <a:lnRef idx="2">
-            <a:schemeClr val="accent1"/>
-          </a:lnRef>
-          <a:fillRef idx="0">
-            <a:schemeClr val="accent1"/>
-          </a:fillRef>
-          <a:effectRef idx="1">
-            <a:schemeClr val="accent1"/>
-          </a:effectRef>
-          <a:fontRef idx="minor">
-            <a:schemeClr val="tx1"/>
-          </a:fontRef>
-        </p:style>
-      </p:cxnSp>
-      <p:sp>
-        <p:nvSpPr>
-          <p:cNvPr id="3" name="タイトル プレースホルダー 1">
-            <a:extLst>
-              <a:ext uri="{FF2B5EF4-FFF2-40B4-BE49-F238E27FC236}">
-                <a16:creationId xmlns:a16="http://schemas.microsoft.com/office/drawing/2014/main" id="{02B030B6-2F82-3D76-693F-FF8F6A794BDA}"/>
-              </a:ext>
-            </a:extLst>
-          </p:cNvPr>
-          <p:cNvSpPr txBox="1">
-            <a:spLocks/>
-          </p:cNvSpPr>
-          <p:nvPr/>
-        </p:nvSpPr>
-        <p:spPr>
-          <a:xfrm>
-            <a:off x="355600" y="1108076"/>
-            <a:ext cx="11506200" cy="812797"/>
-          </a:xfrm>
-          <a:prstGeom prst="rect">
-            <a:avLst/>
-          </a:prstGeom>
-        </p:spPr>
-        <p:txBody>
-          <a:bodyPr vert="horz" lIns="91440" tIns="45720" rIns="91440" bIns="45720" rtlCol="0" anchor="ctr">
-            <a:noAutofit/>
-          </a:bodyPr>
-          <a:lstStyle>
-            <a:lvl1pPr algn="l" defTabSz="914400" rtl="0" eaLnBrk="1" latinLnBrk="0" hangingPunct="1">
-              <a:lnSpc>
-                <a:spcPct val="90000"/>
-              </a:lnSpc>
-              <a:spcBef>
-                <a:spcPct val="0"/>
-              </a:spcBef>
-              <a:buNone/>
-              <a:defRPr kumimoji="1" sz="1400" kern="1200">
-                <a:solidFill>
-                  <a:schemeClr val="tx1"/>
-                </a:solidFill>
-                <a:latin typeface="+mj-lt"/>
-                <a:ea typeface="+mj-ea"/>
-                <a:cs typeface="+mj-cs"/>
-              </a:defRPr>
-            </a:lvl1pPr>
-          </a:lstStyle>
-          <a:p>
-            <a:r>
-              <a:rPr lang="ja-JP" altLang="en-US" sz="2800" dirty="0"/>
-              <a:t>共有のセッションストアで、セッション</a:t>
-            </a:r>
-            <a:r>
-              <a:rPr lang="en-US" altLang="ja-JP" sz="2800" dirty="0"/>
-              <a:t>ID</a:t>
-            </a:r>
-            <a:r>
-              <a:rPr lang="ja-JP" altLang="en-US" sz="2800" dirty="0"/>
-              <a:t>による管理をすれば、異なるサーバにアクセスしたとしても目的の情報が返ってくる。</a:t>
-            </a:r>
-            <a:endParaRPr lang="en-US" altLang="ja-JP" sz="2800" dirty="0"/>
-          </a:p>
-        </p:txBody>
-      </p:sp>
-      <p:sp>
-        <p:nvSpPr>
-          <p:cNvPr id="4" name="タイトル プレースホルダー 1">
-            <a:extLst>
-              <a:ext uri="{FF2B5EF4-FFF2-40B4-BE49-F238E27FC236}">
-                <a16:creationId xmlns:a16="http://schemas.microsoft.com/office/drawing/2014/main" id="{3E8F089A-9AB5-5730-0321-D3BD2781FF59}"/>
-              </a:ext>
-            </a:extLst>
-          </p:cNvPr>
-          <p:cNvSpPr txBox="1">
-            <a:spLocks/>
-          </p:cNvSpPr>
-          <p:nvPr/>
-        </p:nvSpPr>
-        <p:spPr>
-          <a:xfrm>
-            <a:off x="355600" y="546100"/>
-            <a:ext cx="11506200" cy="488949"/>
-          </a:xfrm>
-          <a:prstGeom prst="rect">
-            <a:avLst/>
-          </a:prstGeom>
-        </p:spPr>
-        <p:txBody>
-          <a:bodyPr vert="horz" lIns="91440" tIns="45720" rIns="91440" bIns="45720" rtlCol="0" anchor="ctr">
-            <a:noAutofit/>
-          </a:bodyPr>
-          <a:lstStyle>
-            <a:lvl1pPr algn="l" defTabSz="914400" rtl="0" eaLnBrk="1" latinLnBrk="0" hangingPunct="1">
-              <a:lnSpc>
-                <a:spcPct val="90000"/>
-              </a:lnSpc>
-              <a:spcBef>
-                <a:spcPct val="0"/>
-              </a:spcBef>
-              <a:buNone/>
-              <a:defRPr kumimoji="1" sz="1400" kern="1200">
-                <a:solidFill>
-                  <a:schemeClr val="tx1"/>
-                </a:solidFill>
-                <a:latin typeface="+mj-lt"/>
-                <a:ea typeface="+mj-ea"/>
-                <a:cs typeface="+mj-cs"/>
-              </a:defRPr>
-            </a:lvl1pPr>
-          </a:lstStyle>
-          <a:p>
-            <a:r>
-              <a:rPr lang="ja-JP" altLang="en-US" dirty="0"/>
-              <a:t>セッションを用いた認証方式</a:t>
-            </a:r>
-            <a:endParaRPr lang="en-US" altLang="ja-JP" dirty="0"/>
-          </a:p>
-        </p:txBody>
-      </p:sp>
-      <p:sp>
-        <p:nvSpPr>
-          <p:cNvPr id="6" name="フローチャート: 処理 5">
-            <a:extLst>
-              <a:ext uri="{FF2B5EF4-FFF2-40B4-BE49-F238E27FC236}">
-                <a16:creationId xmlns:a16="http://schemas.microsoft.com/office/drawing/2014/main" id="{2D3CB13F-835E-0809-45B5-763CB46C87F4}"/>
-              </a:ext>
-            </a:extLst>
-          </p:cNvPr>
-          <p:cNvSpPr/>
-          <p:nvPr/>
-        </p:nvSpPr>
-        <p:spPr>
-          <a:xfrm>
-            <a:off x="355600" y="2472401"/>
-            <a:ext cx="1920240" cy="814646"/>
-          </a:xfrm>
-          <a:prstGeom prst="flowChartProcess">
-            <a:avLst/>
-          </a:prstGeom>
-          <a:ln>
-            <a:noFill/>
-          </a:ln>
-        </p:spPr>
-        <p:style>
-          <a:lnRef idx="2">
-            <a:schemeClr val="accent1">
-              <a:shade val="15000"/>
-            </a:schemeClr>
-          </a:lnRef>
-          <a:fillRef idx="1">
-            <a:schemeClr val="accent1"/>
-          </a:fillRef>
-          <a:effectRef idx="0">
-            <a:schemeClr val="accent1"/>
-          </a:effectRef>
-          <a:fontRef idx="minor">
-            <a:schemeClr val="lt1"/>
-          </a:fontRef>
-        </p:style>
-        <p:txBody>
-          <a:bodyPr rtlCol="0" anchor="ctr"/>
-          <a:lstStyle/>
-          <a:p>
-            <a:pPr algn="ctr"/>
-            <a:r>
-              <a:rPr kumimoji="1" lang="ja-JP" altLang="en-US" dirty="0">
-                <a:solidFill>
-                  <a:schemeClr val="tx1">
-                    <a:lumMod val="75000"/>
-                  </a:schemeClr>
-                </a:solidFill>
-              </a:rPr>
-              <a:t>クライアント</a:t>
-            </a:r>
-            <a:endParaRPr kumimoji="1" lang="en-US" altLang="ja-JP" dirty="0">
-              <a:solidFill>
-                <a:schemeClr val="tx1">
-                  <a:lumMod val="75000"/>
-                </a:schemeClr>
-              </a:solidFill>
-            </a:endParaRPr>
-          </a:p>
-          <a:p>
-            <a:pPr algn="ctr"/>
-            <a:r>
-              <a:rPr lang="en-US" altLang="ja-JP" dirty="0">
-                <a:solidFill>
-                  <a:schemeClr val="tx1">
-                    <a:lumMod val="75000"/>
-                  </a:schemeClr>
-                </a:solidFill>
-              </a:rPr>
-              <a:t>(</a:t>
-            </a:r>
-            <a:r>
-              <a:rPr lang="ja-JP" altLang="en-US" dirty="0">
-                <a:solidFill>
-                  <a:schemeClr val="tx1">
-                    <a:lumMod val="75000"/>
-                  </a:schemeClr>
-                </a:solidFill>
-              </a:rPr>
-              <a:t>ブラウザ等</a:t>
-            </a:r>
-            <a:r>
-              <a:rPr lang="en-US" altLang="ja-JP" dirty="0">
-                <a:solidFill>
-                  <a:schemeClr val="tx1">
-                    <a:lumMod val="75000"/>
-                  </a:schemeClr>
-                </a:solidFill>
-              </a:rPr>
-              <a:t>)</a:t>
-            </a:r>
-            <a:endParaRPr kumimoji="1" lang="ja-JP" altLang="en-US" dirty="0">
-              <a:solidFill>
-                <a:schemeClr val="tx1">
-                  <a:lumMod val="75000"/>
-                </a:schemeClr>
-              </a:solidFill>
-            </a:endParaRPr>
-          </a:p>
-        </p:txBody>
-      </p:sp>
-      <p:sp>
-        <p:nvSpPr>
-          <p:cNvPr id="7" name="フローチャート: 処理 6">
-            <a:extLst>
-              <a:ext uri="{FF2B5EF4-FFF2-40B4-BE49-F238E27FC236}">
-                <a16:creationId xmlns:a16="http://schemas.microsoft.com/office/drawing/2014/main" id="{0FB4BC16-C126-6F78-EBC6-92C145832CD3}"/>
-              </a:ext>
-            </a:extLst>
-          </p:cNvPr>
-          <p:cNvSpPr/>
-          <p:nvPr/>
-        </p:nvSpPr>
-        <p:spPr>
-          <a:xfrm>
-            <a:off x="4421458" y="2472401"/>
-            <a:ext cx="1920240" cy="814646"/>
-          </a:xfrm>
-          <a:prstGeom prst="flowChartProcess">
-            <a:avLst/>
-          </a:prstGeom>
-          <a:ln>
-            <a:noFill/>
-          </a:ln>
-        </p:spPr>
-        <p:style>
-          <a:lnRef idx="2">
-            <a:schemeClr val="accent1">
-              <a:shade val="15000"/>
-            </a:schemeClr>
-          </a:lnRef>
-          <a:fillRef idx="1">
-            <a:schemeClr val="accent1"/>
-          </a:fillRef>
-          <a:effectRef idx="0">
-            <a:schemeClr val="accent1"/>
-          </a:effectRef>
-          <a:fontRef idx="minor">
-            <a:schemeClr val="lt1"/>
-          </a:fontRef>
-        </p:style>
-        <p:txBody>
-          <a:bodyPr rtlCol="0" anchor="ctr"/>
-          <a:lstStyle/>
-          <a:p>
-            <a:pPr algn="ctr"/>
-            <a:r>
-              <a:rPr kumimoji="1" lang="ja-JP" altLang="en-US" dirty="0">
-                <a:solidFill>
-                  <a:schemeClr val="tx1">
-                    <a:lumMod val="75000"/>
-                  </a:schemeClr>
-                </a:solidFill>
-              </a:rPr>
-              <a:t>サーバ</a:t>
-            </a:r>
-            <a:r>
-              <a:rPr kumimoji="1" lang="en-US" altLang="ja-JP" dirty="0">
-                <a:solidFill>
-                  <a:schemeClr val="tx1">
-                    <a:lumMod val="75000"/>
-                  </a:schemeClr>
-                </a:solidFill>
-              </a:rPr>
-              <a:t>A</a:t>
-            </a:r>
-          </a:p>
-        </p:txBody>
-      </p:sp>
-      <p:cxnSp>
-        <p:nvCxnSpPr>
-          <p:cNvPr id="8" name="直線コネクタ 7">
-            <a:extLst>
-              <a:ext uri="{FF2B5EF4-FFF2-40B4-BE49-F238E27FC236}">
-                <a16:creationId xmlns:a16="http://schemas.microsoft.com/office/drawing/2014/main" id="{A6DDCE87-042B-E6D0-2658-B5A01D45C85B}"/>
-              </a:ext>
-            </a:extLst>
-          </p:cNvPr>
-          <p:cNvCxnSpPr>
-            <a:stCxn id="6" idx="2"/>
-          </p:cNvCxnSpPr>
-          <p:nvPr/>
-        </p:nvCxnSpPr>
-        <p:spPr>
-          <a:xfrm>
-            <a:off x="1315720" y="3287047"/>
-            <a:ext cx="1451" cy="3052950"/>
-          </a:xfrm>
-          <a:prstGeom prst="line">
-            <a:avLst/>
-          </a:prstGeom>
-        </p:spPr>
-        <p:style>
-          <a:lnRef idx="2">
-            <a:schemeClr val="accent1"/>
-          </a:lnRef>
-          <a:fillRef idx="0">
-            <a:schemeClr val="accent1"/>
-          </a:fillRef>
-          <a:effectRef idx="1">
-            <a:schemeClr val="accent1"/>
-          </a:effectRef>
-          <a:fontRef idx="minor">
-            <a:schemeClr val="tx1"/>
-          </a:fontRef>
-        </p:style>
-      </p:cxnSp>
-      <p:cxnSp>
-        <p:nvCxnSpPr>
-          <p:cNvPr id="9" name="直線コネクタ 8">
-            <a:extLst>
-              <a:ext uri="{FF2B5EF4-FFF2-40B4-BE49-F238E27FC236}">
-                <a16:creationId xmlns:a16="http://schemas.microsoft.com/office/drawing/2014/main" id="{479B5EC8-48E1-93E3-0E3A-F5ACE8FA021A}"/>
-              </a:ext>
-            </a:extLst>
-          </p:cNvPr>
-          <p:cNvCxnSpPr>
-            <a:stCxn id="7" idx="2"/>
-          </p:cNvCxnSpPr>
-          <p:nvPr/>
-        </p:nvCxnSpPr>
-        <p:spPr>
-          <a:xfrm>
-            <a:off x="5381578" y="3287047"/>
-            <a:ext cx="31206" cy="3129150"/>
-          </a:xfrm>
-          <a:prstGeom prst="line">
-            <a:avLst/>
-          </a:prstGeom>
-        </p:spPr>
-        <p:style>
-          <a:lnRef idx="2">
-            <a:schemeClr val="accent1"/>
-          </a:lnRef>
-          <a:fillRef idx="0">
-            <a:schemeClr val="accent1"/>
-          </a:fillRef>
-          <a:effectRef idx="1">
-            <a:schemeClr val="accent1"/>
-          </a:effectRef>
-          <a:fontRef idx="minor">
-            <a:schemeClr val="tx1"/>
-          </a:fontRef>
-        </p:style>
-      </p:cxnSp>
-      <p:cxnSp>
-        <p:nvCxnSpPr>
-          <p:cNvPr id="10" name="直線矢印コネクタ 9">
-            <a:extLst>
-              <a:ext uri="{FF2B5EF4-FFF2-40B4-BE49-F238E27FC236}">
-                <a16:creationId xmlns:a16="http://schemas.microsoft.com/office/drawing/2014/main" id="{13CD9B52-4D27-9218-98BD-560392B30835}"/>
-              </a:ext>
-            </a:extLst>
-          </p:cNvPr>
-          <p:cNvCxnSpPr>
-            <a:cxnSpLocks/>
-            <a:endCxn id="15" idx="1"/>
-          </p:cNvCxnSpPr>
-          <p:nvPr/>
-        </p:nvCxnSpPr>
-        <p:spPr>
-          <a:xfrm>
-            <a:off x="1315720" y="3923369"/>
-            <a:ext cx="3105738" cy="842401"/>
-          </a:xfrm>
-          <a:prstGeom prst="straightConnector1">
-            <a:avLst/>
-          </a:prstGeom>
-          <a:ln w="44450">
-            <a:tailEnd type="triangle"/>
-          </a:ln>
-        </p:spPr>
-        <p:style>
-          <a:lnRef idx="2">
-            <a:schemeClr val="accent1"/>
-          </a:lnRef>
-          <a:fillRef idx="0">
-            <a:schemeClr val="accent1"/>
-          </a:fillRef>
-          <a:effectRef idx="1">
-            <a:schemeClr val="accent1"/>
-          </a:effectRef>
-          <a:fontRef idx="minor">
-            <a:schemeClr val="tx1"/>
-          </a:fontRef>
-        </p:style>
-      </p:cxnSp>
-      <p:cxnSp>
-        <p:nvCxnSpPr>
-          <p:cNvPr id="11" name="直線矢印コネクタ 10">
-            <a:extLst>
-              <a:ext uri="{FF2B5EF4-FFF2-40B4-BE49-F238E27FC236}">
-                <a16:creationId xmlns:a16="http://schemas.microsoft.com/office/drawing/2014/main" id="{FB276DBC-CCA3-20EB-205E-D2CAF72440B5}"/>
-              </a:ext>
-            </a:extLst>
-          </p:cNvPr>
-          <p:cNvCxnSpPr>
-            <a:cxnSpLocks/>
-          </p:cNvCxnSpPr>
-          <p:nvPr/>
-        </p:nvCxnSpPr>
-        <p:spPr>
-          <a:xfrm flipH="1">
-            <a:off x="1315720" y="6236879"/>
-            <a:ext cx="4097064" cy="0"/>
-          </a:xfrm>
-          <a:prstGeom prst="straightConnector1">
-            <a:avLst/>
-          </a:prstGeom>
-          <a:ln w="44450">
-            <a:tailEnd type="triangle"/>
-          </a:ln>
-        </p:spPr>
-        <p:style>
-          <a:lnRef idx="2">
-            <a:schemeClr val="accent1"/>
-          </a:lnRef>
-          <a:fillRef idx="0">
-            <a:schemeClr val="accent1"/>
-          </a:fillRef>
-          <a:effectRef idx="1">
-            <a:schemeClr val="accent1"/>
-          </a:effectRef>
-          <a:fontRef idx="minor">
-            <a:schemeClr val="tx1"/>
-          </a:fontRef>
-        </p:style>
-      </p:cxnSp>
-      <p:sp>
-        <p:nvSpPr>
-          <p:cNvPr id="12" name="フローチャート: 処理 11">
-            <a:extLst>
-              <a:ext uri="{FF2B5EF4-FFF2-40B4-BE49-F238E27FC236}">
-                <a16:creationId xmlns:a16="http://schemas.microsoft.com/office/drawing/2014/main" id="{18944945-24C9-90FA-0529-7B602F9F36FF}"/>
-              </a:ext>
-            </a:extLst>
-          </p:cNvPr>
-          <p:cNvSpPr/>
-          <p:nvPr/>
-        </p:nvSpPr>
-        <p:spPr>
-          <a:xfrm>
-            <a:off x="7301818" y="2472401"/>
-            <a:ext cx="1920240" cy="814646"/>
-          </a:xfrm>
-          <a:prstGeom prst="flowChartProcess">
-            <a:avLst/>
-          </a:prstGeom>
-          <a:ln>
-            <a:noFill/>
-          </a:ln>
-        </p:spPr>
-        <p:style>
-          <a:lnRef idx="2">
-            <a:schemeClr val="accent1">
-              <a:shade val="15000"/>
-            </a:schemeClr>
-          </a:lnRef>
-          <a:fillRef idx="1">
-            <a:schemeClr val="accent1"/>
-          </a:fillRef>
-          <a:effectRef idx="0">
-            <a:schemeClr val="accent1"/>
-          </a:effectRef>
-          <a:fontRef idx="minor">
-            <a:schemeClr val="lt1"/>
-          </a:fontRef>
-        </p:style>
-        <p:txBody>
-          <a:bodyPr rtlCol="0" anchor="ctr"/>
-          <a:lstStyle/>
-          <a:p>
-            <a:pPr algn="ctr"/>
-            <a:r>
-              <a:rPr kumimoji="1" lang="ja-JP" altLang="en-US" dirty="0">
-                <a:solidFill>
-                  <a:schemeClr val="tx1">
-                    <a:lumMod val="75000"/>
-                  </a:schemeClr>
-                </a:solidFill>
-              </a:rPr>
-              <a:t>セッションストア</a:t>
-            </a:r>
-          </a:p>
-        </p:txBody>
-      </p:sp>
-      <p:cxnSp>
-        <p:nvCxnSpPr>
-          <p:cNvPr id="13" name="直線コネクタ 12">
-            <a:extLst>
-              <a:ext uri="{FF2B5EF4-FFF2-40B4-BE49-F238E27FC236}">
-                <a16:creationId xmlns:a16="http://schemas.microsoft.com/office/drawing/2014/main" id="{2853CB51-9733-80B0-28D0-429DD3DA70B9}"/>
-              </a:ext>
-            </a:extLst>
-          </p:cNvPr>
-          <p:cNvCxnSpPr>
-            <a:stCxn id="12" idx="2"/>
-          </p:cNvCxnSpPr>
-          <p:nvPr/>
-        </p:nvCxnSpPr>
-        <p:spPr>
-          <a:xfrm>
-            <a:off x="8261938" y="3287047"/>
-            <a:ext cx="31206" cy="3129150"/>
-          </a:xfrm>
-          <a:prstGeom prst="line">
-            <a:avLst/>
-          </a:prstGeom>
-        </p:spPr>
-        <p:style>
-          <a:lnRef idx="2">
-            <a:schemeClr val="accent1"/>
-          </a:lnRef>
-          <a:fillRef idx="0">
-            <a:schemeClr val="accent1"/>
-          </a:fillRef>
-          <a:effectRef idx="1">
-            <a:schemeClr val="accent1"/>
-          </a:effectRef>
-          <a:fontRef idx="minor">
-            <a:schemeClr val="tx1"/>
-          </a:fontRef>
-        </p:style>
-      </p:cxnSp>
-      <p:cxnSp>
-        <p:nvCxnSpPr>
-          <p:cNvPr id="16" name="直線矢印コネクタ 15">
-            <a:extLst>
-              <a:ext uri="{FF2B5EF4-FFF2-40B4-BE49-F238E27FC236}">
-                <a16:creationId xmlns:a16="http://schemas.microsoft.com/office/drawing/2014/main" id="{8376B734-BE36-355B-3240-CA9B93472A13}"/>
-              </a:ext>
-            </a:extLst>
-          </p:cNvPr>
-          <p:cNvCxnSpPr>
-            <a:cxnSpLocks/>
-          </p:cNvCxnSpPr>
-          <p:nvPr/>
-        </p:nvCxnSpPr>
-        <p:spPr>
-          <a:xfrm>
-            <a:off x="5372323" y="5685666"/>
-            <a:ext cx="2905218" cy="0"/>
-          </a:xfrm>
-          <a:prstGeom prst="straightConnector1">
-            <a:avLst/>
-          </a:prstGeom>
-          <a:ln w="44450">
-            <a:tailEnd type="triangle"/>
-          </a:ln>
-        </p:spPr>
-        <p:style>
-          <a:lnRef idx="2">
-            <a:schemeClr val="accent1"/>
-          </a:lnRef>
-          <a:fillRef idx="0">
-            <a:schemeClr val="accent1"/>
-          </a:fillRef>
-          <a:effectRef idx="1">
-            <a:schemeClr val="accent1"/>
-          </a:effectRef>
-          <a:fontRef idx="minor">
-            <a:schemeClr val="tx1"/>
-          </a:fontRef>
-        </p:style>
-      </p:cxnSp>
-      <p:sp>
-        <p:nvSpPr>
-          <p:cNvPr id="17" name="テキスト ボックス 16">
-            <a:extLst>
-              <a:ext uri="{FF2B5EF4-FFF2-40B4-BE49-F238E27FC236}">
-                <a16:creationId xmlns:a16="http://schemas.microsoft.com/office/drawing/2014/main" id="{1BF24439-8ED8-CF3D-5BE2-D0F31C72E601}"/>
-              </a:ext>
-            </a:extLst>
-          </p:cNvPr>
-          <p:cNvSpPr txBox="1"/>
-          <p:nvPr/>
-        </p:nvSpPr>
-        <p:spPr>
-          <a:xfrm>
-            <a:off x="5372323" y="5380957"/>
-            <a:ext cx="2346275" cy="276999"/>
-          </a:xfrm>
-          <a:prstGeom prst="rect">
-            <a:avLst/>
-          </a:prstGeom>
-          <a:noFill/>
-        </p:spPr>
-        <p:txBody>
-          <a:bodyPr wrap="square" rtlCol="0">
-            <a:spAutoFit/>
-          </a:bodyPr>
-          <a:lstStyle/>
-          <a:p>
-            <a:r>
-              <a:rPr kumimoji="1" lang="en-US" altLang="ja-JP" sz="1200" dirty="0"/>
-              <a:t>abc123</a:t>
-            </a:r>
-            <a:r>
-              <a:rPr lang="ja-JP" altLang="en-US" sz="1200" dirty="0"/>
-              <a:t>を</a:t>
-            </a:r>
-            <a:r>
-              <a:rPr lang="en-US" altLang="ja-JP" sz="1200" dirty="0" err="1"/>
-              <a:t>session_id</a:t>
-            </a:r>
-            <a:r>
-              <a:rPr lang="ja-JP" altLang="en-US" sz="1200" dirty="0"/>
-              <a:t>として検索</a:t>
-            </a:r>
-            <a:endParaRPr kumimoji="1" lang="ja-JP" altLang="en-US" sz="1200" dirty="0"/>
-          </a:p>
-        </p:txBody>
-      </p:sp>
-      <p:graphicFrame>
-        <p:nvGraphicFramePr>
-          <p:cNvPr id="18" name="表 17">
-            <a:extLst>
-              <a:ext uri="{FF2B5EF4-FFF2-40B4-BE49-F238E27FC236}">
-                <a16:creationId xmlns:a16="http://schemas.microsoft.com/office/drawing/2014/main" id="{03697418-9D28-4A6D-F79F-ED39A714B6CD}"/>
-              </a:ext>
-            </a:extLst>
-          </p:cNvPr>
-          <p:cNvGraphicFramePr>
-            <a:graphicFrameLocks noGrp="1"/>
-          </p:cNvGraphicFramePr>
-          <p:nvPr/>
-        </p:nvGraphicFramePr>
-        <p:xfrm>
-          <a:off x="8410894" y="4317535"/>
-          <a:ext cx="3677856" cy="1233780"/>
-        </p:xfrm>
-        <a:graphic>
-          <a:graphicData uri="http://schemas.openxmlformats.org/drawingml/2006/table">
-            <a:tbl>
-              <a:tblPr firstRow="1" bandRow="1">
-                <a:tableStyleId>{5C22544A-7EE6-4342-B048-85BDC9FD1C3A}</a:tableStyleId>
-              </a:tblPr>
-              <a:tblGrid>
-                <a:gridCol w="1057302">
-                  <a:extLst>
-                    <a:ext uri="{9D8B030D-6E8A-4147-A177-3AD203B41FA5}">
-                      <a16:colId xmlns:a16="http://schemas.microsoft.com/office/drawing/2014/main" val="3227126631"/>
-                    </a:ext>
-                  </a:extLst>
-                </a:gridCol>
-                <a:gridCol w="1296786">
-                  <a:extLst>
-                    <a:ext uri="{9D8B030D-6E8A-4147-A177-3AD203B41FA5}">
-                      <a16:colId xmlns:a16="http://schemas.microsoft.com/office/drawing/2014/main" val="3304654069"/>
-                    </a:ext>
-                  </a:extLst>
-                </a:gridCol>
-                <a:gridCol w="1323768">
-                  <a:extLst>
-                    <a:ext uri="{9D8B030D-6E8A-4147-A177-3AD203B41FA5}">
-                      <a16:colId xmlns:a16="http://schemas.microsoft.com/office/drawing/2014/main" val="712856723"/>
-                    </a:ext>
-                  </a:extLst>
-                </a:gridCol>
-              </a:tblGrid>
-              <a:tr h="308445">
-                <a:tc>
-                  <a:txBody>
-                    <a:bodyPr/>
-                    <a:lstStyle/>
-                    <a:p>
-                      <a:r>
-                        <a:rPr kumimoji="1" lang="en-US" altLang="ja-JP" sz="1500" dirty="0" err="1">
-                          <a:solidFill>
-                            <a:schemeClr val="tx1">
-                              <a:lumMod val="75000"/>
-                            </a:schemeClr>
-                          </a:solidFill>
-                        </a:rPr>
-                        <a:t>User_id</a:t>
-                      </a:r>
-                      <a:endParaRPr kumimoji="1" lang="ja-JP" altLang="en-US" sz="1500" dirty="0">
-                        <a:solidFill>
-                          <a:schemeClr val="tx1">
-                            <a:lumMod val="75000"/>
-                          </a:schemeClr>
-                        </a:solidFill>
-                      </a:endParaRPr>
-                    </a:p>
-                  </a:txBody>
-                  <a:tcPr marL="77111" marR="77111" marT="38556" marB="38556"/>
-                </a:tc>
-                <a:tc>
-                  <a:txBody>
-                    <a:bodyPr/>
-                    <a:lstStyle/>
-                    <a:p>
-                      <a:r>
-                        <a:rPr kumimoji="1" lang="en-US" altLang="ja-JP" sz="1500" dirty="0" err="1">
-                          <a:solidFill>
-                            <a:schemeClr val="tx1">
-                              <a:lumMod val="75000"/>
-                            </a:schemeClr>
-                          </a:solidFill>
-                        </a:rPr>
-                        <a:t>Session_id</a:t>
-                      </a:r>
-                      <a:endParaRPr kumimoji="1" lang="ja-JP" altLang="en-US" sz="1500" dirty="0">
-                        <a:solidFill>
-                          <a:schemeClr val="tx1">
-                            <a:lumMod val="75000"/>
-                          </a:schemeClr>
-                        </a:solidFill>
-                      </a:endParaRPr>
-                    </a:p>
-                  </a:txBody>
-                  <a:tcPr marL="77111" marR="77111" marT="38556" marB="38556"/>
-                </a:tc>
-                <a:tc>
-                  <a:txBody>
-                    <a:bodyPr/>
-                    <a:lstStyle/>
-                    <a:p>
-                      <a:r>
-                        <a:rPr kumimoji="1" lang="en-US" altLang="ja-JP" sz="1500" dirty="0" err="1">
-                          <a:solidFill>
-                            <a:schemeClr val="tx1">
-                              <a:lumMod val="75000"/>
-                            </a:schemeClr>
-                          </a:solidFill>
-                        </a:rPr>
-                        <a:t>Expires_at</a:t>
-                      </a:r>
-                      <a:endParaRPr kumimoji="1" lang="ja-JP" altLang="en-US" sz="1500" dirty="0">
-                        <a:solidFill>
-                          <a:schemeClr val="tx1">
-                            <a:lumMod val="75000"/>
-                          </a:schemeClr>
-                        </a:solidFill>
-                      </a:endParaRPr>
-                    </a:p>
-                  </a:txBody>
-                  <a:tcPr marL="77111" marR="77111" marT="38556" marB="38556"/>
-                </a:tc>
-                <a:extLst>
-                  <a:ext uri="{0D108BD9-81ED-4DB2-BD59-A6C34878D82A}">
-                    <a16:rowId xmlns:a16="http://schemas.microsoft.com/office/drawing/2014/main" val="2756609583"/>
-                  </a:ext>
-                </a:extLst>
-              </a:tr>
-              <a:tr h="308445">
-                <a:tc>
-                  <a:txBody>
-                    <a:bodyPr/>
-                    <a:lstStyle/>
-                    <a:p>
-                      <a:r>
-                        <a:rPr kumimoji="1" lang="en-US" altLang="ja-JP" sz="1500" dirty="0">
-                          <a:solidFill>
-                            <a:schemeClr val="tx1">
-                              <a:lumMod val="75000"/>
-                            </a:schemeClr>
-                          </a:solidFill>
-                        </a:rPr>
-                        <a:t>hiroki01</a:t>
-                      </a:r>
-                      <a:endParaRPr kumimoji="1" lang="ja-JP" altLang="en-US" sz="1500" dirty="0">
-                        <a:solidFill>
-                          <a:schemeClr val="tx1">
-                            <a:lumMod val="75000"/>
-                          </a:schemeClr>
-                        </a:solidFill>
-                      </a:endParaRPr>
-                    </a:p>
-                  </a:txBody>
-                  <a:tcPr marL="77111" marR="77111" marT="38556" marB="38556"/>
-                </a:tc>
-                <a:tc>
-                  <a:txBody>
-                    <a:bodyPr/>
-                    <a:lstStyle/>
-                    <a:p>
-                      <a:r>
-                        <a:rPr kumimoji="1" lang="en-US" altLang="ja-JP" sz="1500" dirty="0">
-                          <a:solidFill>
-                            <a:schemeClr val="tx1">
-                              <a:lumMod val="75000"/>
-                            </a:schemeClr>
-                          </a:solidFill>
-                        </a:rPr>
-                        <a:t>abc123</a:t>
-                      </a:r>
-                      <a:endParaRPr kumimoji="1" lang="ja-JP" altLang="en-US" sz="1500" dirty="0">
-                        <a:solidFill>
-                          <a:schemeClr val="tx1">
-                            <a:lumMod val="75000"/>
-                          </a:schemeClr>
-                        </a:solidFill>
-                      </a:endParaRPr>
-                    </a:p>
-                  </a:txBody>
-                  <a:tcPr marL="77111" marR="77111" marT="38556" marB="38556"/>
-                </a:tc>
-                <a:tc>
-                  <a:txBody>
-                    <a:bodyPr/>
-                    <a:lstStyle/>
-                    <a:p>
-                      <a:r>
-                        <a:rPr kumimoji="1" lang="en-US" altLang="ja-JP" sz="1500" dirty="0">
-                          <a:solidFill>
-                            <a:schemeClr val="tx1">
-                              <a:lumMod val="75000"/>
-                            </a:schemeClr>
-                          </a:solidFill>
-                        </a:rPr>
-                        <a:t>14:50:22</a:t>
-                      </a:r>
-                      <a:endParaRPr kumimoji="1" lang="ja-JP" altLang="en-US" sz="1500" dirty="0">
-                        <a:solidFill>
-                          <a:schemeClr val="tx1">
-                            <a:lumMod val="75000"/>
-                          </a:schemeClr>
-                        </a:solidFill>
-                      </a:endParaRPr>
-                    </a:p>
-                  </a:txBody>
-                  <a:tcPr marL="77111" marR="77111" marT="38556" marB="38556"/>
-                </a:tc>
-                <a:extLst>
-                  <a:ext uri="{0D108BD9-81ED-4DB2-BD59-A6C34878D82A}">
-                    <a16:rowId xmlns:a16="http://schemas.microsoft.com/office/drawing/2014/main" val="3273612845"/>
-                  </a:ext>
-                </a:extLst>
-              </a:tr>
-              <a:tr h="308445">
-                <a:tc>
-                  <a:txBody>
-                    <a:bodyPr/>
-                    <a:lstStyle/>
-                    <a:p>
-                      <a:r>
-                        <a:rPr kumimoji="1" lang="en-US" altLang="ja-JP" sz="1500" dirty="0">
-                          <a:solidFill>
-                            <a:schemeClr val="tx1">
-                              <a:lumMod val="75000"/>
-                            </a:schemeClr>
-                          </a:solidFill>
-                        </a:rPr>
-                        <a:t>morita01</a:t>
-                      </a:r>
-                      <a:endParaRPr kumimoji="1" lang="ja-JP" altLang="en-US" sz="1500" dirty="0">
-                        <a:solidFill>
-                          <a:schemeClr val="tx1">
-                            <a:lumMod val="75000"/>
-                          </a:schemeClr>
-                        </a:solidFill>
-                      </a:endParaRPr>
-                    </a:p>
-                  </a:txBody>
-                  <a:tcPr marL="77111" marR="77111" marT="38556" marB="38556"/>
-                </a:tc>
-                <a:tc>
-                  <a:txBody>
-                    <a:bodyPr/>
-                    <a:lstStyle/>
-                    <a:p>
-                      <a:r>
-                        <a:rPr kumimoji="1" lang="en-US" altLang="ja-JP" sz="1500" dirty="0">
-                          <a:solidFill>
-                            <a:schemeClr val="tx1">
-                              <a:lumMod val="75000"/>
-                            </a:schemeClr>
-                          </a:solidFill>
-                        </a:rPr>
-                        <a:t>efj466</a:t>
-                      </a:r>
-                      <a:endParaRPr kumimoji="1" lang="ja-JP" altLang="en-US" sz="1500" dirty="0">
-                        <a:solidFill>
-                          <a:schemeClr val="tx1">
-                            <a:lumMod val="75000"/>
-                          </a:schemeClr>
-                        </a:solidFill>
-                      </a:endParaRPr>
-                    </a:p>
-                  </a:txBody>
-                  <a:tcPr marL="77111" marR="77111" marT="38556" marB="38556"/>
-                </a:tc>
-                <a:tc>
-                  <a:txBody>
-                    <a:bodyPr/>
-                    <a:lstStyle/>
-                    <a:p>
-                      <a:r>
-                        <a:rPr kumimoji="1" lang="en-US" altLang="ja-JP" sz="1500" dirty="0">
-                          <a:solidFill>
-                            <a:schemeClr val="tx1">
-                              <a:lumMod val="75000"/>
-                            </a:schemeClr>
-                          </a:solidFill>
-                        </a:rPr>
-                        <a:t>17:20:31</a:t>
-                      </a:r>
-                      <a:endParaRPr kumimoji="1" lang="ja-JP" altLang="en-US" sz="1500" dirty="0">
-                        <a:solidFill>
-                          <a:schemeClr val="tx1">
-                            <a:lumMod val="75000"/>
-                          </a:schemeClr>
-                        </a:solidFill>
-                      </a:endParaRPr>
-                    </a:p>
-                  </a:txBody>
-                  <a:tcPr marL="77111" marR="77111" marT="38556" marB="38556"/>
-                </a:tc>
-                <a:extLst>
-                  <a:ext uri="{0D108BD9-81ED-4DB2-BD59-A6C34878D82A}">
-                    <a16:rowId xmlns:a16="http://schemas.microsoft.com/office/drawing/2014/main" val="99341499"/>
-                  </a:ext>
-                </a:extLst>
-              </a:tr>
-              <a:tr h="308445">
-                <a:tc>
-                  <a:txBody>
-                    <a:bodyPr/>
-                    <a:lstStyle/>
-                    <a:p>
-                      <a:r>
-                        <a:rPr kumimoji="1" lang="ja-JP" altLang="en-US" sz="1500" dirty="0">
-                          <a:solidFill>
-                            <a:schemeClr val="tx1">
-                              <a:lumMod val="75000"/>
-                            </a:schemeClr>
-                          </a:solidFill>
-                        </a:rPr>
-                        <a:t>・・・</a:t>
-                      </a:r>
-                    </a:p>
-                  </a:txBody>
-                  <a:tcPr marL="77111" marR="77111" marT="38556" marB="38556"/>
-                </a:tc>
-                <a:tc>
-                  <a:txBody>
-                    <a:bodyPr/>
-                    <a:lstStyle/>
-                    <a:p>
-                      <a:r>
-                        <a:rPr kumimoji="1" lang="ja-JP" altLang="en-US" sz="1500" dirty="0">
-                          <a:solidFill>
-                            <a:schemeClr val="tx1">
-                              <a:lumMod val="75000"/>
-                            </a:schemeClr>
-                          </a:solidFill>
-                        </a:rPr>
-                        <a:t>・・・</a:t>
-                      </a:r>
-                    </a:p>
-                  </a:txBody>
-                  <a:tcPr marL="77111" marR="77111" marT="38556" marB="38556"/>
-                </a:tc>
-                <a:tc>
-                  <a:txBody>
-                    <a:bodyPr/>
-                    <a:lstStyle/>
-                    <a:p>
-                      <a:r>
-                        <a:rPr kumimoji="1" lang="ja-JP" altLang="en-US" sz="1500" dirty="0">
-                          <a:solidFill>
-                            <a:schemeClr val="tx1">
-                              <a:lumMod val="75000"/>
-                            </a:schemeClr>
-                          </a:solidFill>
-                        </a:rPr>
-                        <a:t>・・・</a:t>
-                      </a:r>
-                    </a:p>
-                  </a:txBody>
-                  <a:tcPr marL="77111" marR="77111" marT="38556" marB="38556"/>
-                </a:tc>
-                <a:extLst>
-                  <a:ext uri="{0D108BD9-81ED-4DB2-BD59-A6C34878D82A}">
-                    <a16:rowId xmlns:a16="http://schemas.microsoft.com/office/drawing/2014/main" val="4062019665"/>
-                  </a:ext>
-                </a:extLst>
-              </a:tr>
-            </a:tbl>
-          </a:graphicData>
-        </a:graphic>
-      </p:graphicFrame>
-      <p:sp>
-        <p:nvSpPr>
-          <p:cNvPr id="20" name="テキスト ボックス 19">
-            <a:extLst>
-              <a:ext uri="{FF2B5EF4-FFF2-40B4-BE49-F238E27FC236}">
-                <a16:creationId xmlns:a16="http://schemas.microsoft.com/office/drawing/2014/main" id="{5ABF4178-710C-51DA-95DF-25E1AE10FB25}"/>
-              </a:ext>
-            </a:extLst>
-          </p:cNvPr>
-          <p:cNvSpPr txBox="1"/>
-          <p:nvPr/>
-        </p:nvSpPr>
-        <p:spPr>
-          <a:xfrm>
-            <a:off x="3235070" y="6227088"/>
-            <a:ext cx="2191687" cy="461665"/>
-          </a:xfrm>
-          <a:prstGeom prst="rect">
-            <a:avLst/>
-          </a:prstGeom>
-          <a:noFill/>
-        </p:spPr>
-        <p:txBody>
-          <a:bodyPr wrap="square" rtlCol="0">
-            <a:spAutoFit/>
-          </a:bodyPr>
-          <a:lstStyle/>
-          <a:p>
-            <a:r>
-              <a:rPr kumimoji="1" lang="en-US" altLang="ja-JP" sz="1200" b="1" dirty="0" err="1"/>
-              <a:t>user</a:t>
-            </a:r>
-            <a:r>
-              <a:rPr lang="en-US" altLang="ja-JP" sz="1200" b="1" dirty="0" err="1"/>
-              <a:t>_id</a:t>
-            </a:r>
-            <a:r>
-              <a:rPr lang="en-US" altLang="ja-JP" sz="1200" b="1" dirty="0"/>
-              <a:t> = hiroki01</a:t>
-            </a:r>
-          </a:p>
-          <a:p>
-            <a:r>
-              <a:rPr kumimoji="1" lang="ja-JP" altLang="en-US" sz="1200" b="1" dirty="0"/>
-              <a:t>のページの情報を返却</a:t>
-            </a:r>
-          </a:p>
-        </p:txBody>
-      </p:sp>
-      <p:sp>
-        <p:nvSpPr>
-          <p:cNvPr id="21" name="吹き出し: 円形 20">
-            <a:extLst>
-              <a:ext uri="{FF2B5EF4-FFF2-40B4-BE49-F238E27FC236}">
-                <a16:creationId xmlns:a16="http://schemas.microsoft.com/office/drawing/2014/main" id="{727CDF50-827C-F8DA-EA8B-885466EE2D50}"/>
-              </a:ext>
-            </a:extLst>
-          </p:cNvPr>
-          <p:cNvSpPr/>
-          <p:nvPr/>
-        </p:nvSpPr>
-        <p:spPr>
-          <a:xfrm>
-            <a:off x="1540537" y="4514986"/>
-            <a:ext cx="2337581" cy="925335"/>
-          </a:xfrm>
-          <a:prstGeom prst="wedgeEllipseCallout">
-            <a:avLst>
-              <a:gd name="adj1" fmla="val -33165"/>
-              <a:gd name="adj2" fmla="val -85727"/>
-            </a:avLst>
-          </a:prstGeom>
-        </p:spPr>
-        <p:style>
-          <a:lnRef idx="2">
-            <a:schemeClr val="accent1">
-              <a:shade val="15000"/>
-            </a:schemeClr>
-          </a:lnRef>
-          <a:fillRef idx="1">
-            <a:schemeClr val="accent1"/>
-          </a:fillRef>
-          <a:effectRef idx="0">
-            <a:schemeClr val="accent1"/>
-          </a:effectRef>
-          <a:fontRef idx="minor">
-            <a:schemeClr val="lt1"/>
-          </a:fontRef>
-        </p:style>
-        <p:txBody>
-          <a:bodyPr rtlCol="0" anchor="ctr"/>
-          <a:lstStyle/>
-          <a:p>
-            <a:pPr algn="ctr"/>
-            <a:r>
-              <a:rPr kumimoji="1" lang="ja-JP" altLang="en-US" sz="1400" dirty="0">
-                <a:solidFill>
-                  <a:schemeClr val="tx1">
-                    <a:lumMod val="75000"/>
-                  </a:schemeClr>
-                </a:solidFill>
-              </a:rPr>
-              <a:t>どちらにアクセスしても同じ結果が</a:t>
-            </a:r>
-            <a:endParaRPr kumimoji="1" lang="en-US" altLang="ja-JP" sz="1400" dirty="0">
-              <a:solidFill>
-                <a:schemeClr val="tx1">
-                  <a:lumMod val="75000"/>
-                </a:schemeClr>
-              </a:solidFill>
-            </a:endParaRPr>
-          </a:p>
-          <a:p>
-            <a:pPr algn="ctr"/>
-            <a:r>
-              <a:rPr kumimoji="1" lang="ja-JP" altLang="en-US" sz="1400" dirty="0">
-                <a:solidFill>
-                  <a:schemeClr val="tx1">
-                    <a:lumMod val="75000"/>
-                  </a:schemeClr>
-                </a:solidFill>
-              </a:rPr>
-              <a:t>返ってくる！</a:t>
-            </a:r>
-          </a:p>
-        </p:txBody>
-      </p:sp>
-      <p:cxnSp>
-        <p:nvCxnSpPr>
-          <p:cNvPr id="22" name="直線矢印コネクタ 21">
-            <a:extLst>
-              <a:ext uri="{FF2B5EF4-FFF2-40B4-BE49-F238E27FC236}">
-                <a16:creationId xmlns:a16="http://schemas.microsoft.com/office/drawing/2014/main" id="{A137211D-22A6-9107-F8EC-F641481C2453}"/>
-              </a:ext>
-            </a:extLst>
-          </p:cNvPr>
-          <p:cNvCxnSpPr>
-            <a:cxnSpLocks/>
-          </p:cNvCxnSpPr>
-          <p:nvPr/>
-        </p:nvCxnSpPr>
-        <p:spPr>
-          <a:xfrm flipH="1">
-            <a:off x="5381578" y="6045684"/>
-            <a:ext cx="2880360" cy="0"/>
-          </a:xfrm>
-          <a:prstGeom prst="straightConnector1">
-            <a:avLst/>
-          </a:prstGeom>
-          <a:ln w="44450">
-            <a:tailEnd type="triangle"/>
-          </a:ln>
-        </p:spPr>
-        <p:style>
-          <a:lnRef idx="2">
-            <a:schemeClr val="accent1"/>
-          </a:lnRef>
-          <a:fillRef idx="0">
-            <a:schemeClr val="accent1"/>
-          </a:fillRef>
-          <a:effectRef idx="1">
-            <a:schemeClr val="accent1"/>
-          </a:effectRef>
-          <a:fontRef idx="minor">
-            <a:schemeClr val="tx1"/>
-          </a:fontRef>
-        </p:style>
-      </p:cxnSp>
-      <p:sp>
-        <p:nvSpPr>
-          <p:cNvPr id="24" name="テキスト ボックス 23">
-            <a:extLst>
-              <a:ext uri="{FF2B5EF4-FFF2-40B4-BE49-F238E27FC236}">
-                <a16:creationId xmlns:a16="http://schemas.microsoft.com/office/drawing/2014/main" id="{F87A0FD6-24E4-6BDA-AE6E-1D131F44F775}"/>
-              </a:ext>
-            </a:extLst>
-          </p:cNvPr>
-          <p:cNvSpPr txBox="1"/>
-          <p:nvPr/>
-        </p:nvSpPr>
-        <p:spPr>
-          <a:xfrm>
-            <a:off x="5963495" y="6070932"/>
-            <a:ext cx="2346275" cy="461665"/>
-          </a:xfrm>
-          <a:prstGeom prst="rect">
-            <a:avLst/>
-          </a:prstGeom>
-          <a:noFill/>
-        </p:spPr>
-        <p:txBody>
-          <a:bodyPr wrap="square" rtlCol="0">
-            <a:spAutoFit/>
-          </a:bodyPr>
-          <a:lstStyle/>
-          <a:p>
-            <a:r>
-              <a:rPr lang="en-US" altLang="ja-JP" sz="1200" b="1" dirty="0" err="1"/>
-              <a:t>session_id</a:t>
-            </a:r>
-            <a:r>
-              <a:rPr lang="en-US" altLang="ja-JP" sz="1200" b="1" dirty="0"/>
-              <a:t>=</a:t>
-            </a:r>
-            <a:r>
-              <a:rPr kumimoji="1" lang="en-US" altLang="ja-JP" sz="1200" b="1" dirty="0"/>
-              <a:t>abc123</a:t>
-            </a:r>
-            <a:r>
-              <a:rPr kumimoji="1" lang="ja-JP" altLang="en-US" sz="1200" b="1" dirty="0"/>
-              <a:t>から、該当の</a:t>
-            </a:r>
-            <a:r>
-              <a:rPr kumimoji="1" lang="en-US" altLang="ja-JP" sz="1200" b="1" dirty="0" err="1"/>
-              <a:t>user_id</a:t>
-            </a:r>
-            <a:r>
-              <a:rPr kumimoji="1" lang="ja-JP" altLang="en-US" sz="1200" b="1" dirty="0"/>
-              <a:t>を検索</a:t>
-            </a:r>
-          </a:p>
-        </p:txBody>
-      </p:sp>
-      <p:sp>
-        <p:nvSpPr>
-          <p:cNvPr id="5" name="テキスト ボックス 4">
-            <a:extLst>
-              <a:ext uri="{FF2B5EF4-FFF2-40B4-BE49-F238E27FC236}">
-                <a16:creationId xmlns:a16="http://schemas.microsoft.com/office/drawing/2014/main" id="{9B2BF6D6-646A-67EA-AB45-9A685D0AE9ED}"/>
-              </a:ext>
-            </a:extLst>
-          </p:cNvPr>
-          <p:cNvSpPr txBox="1"/>
-          <p:nvPr/>
-        </p:nvSpPr>
-        <p:spPr>
-          <a:xfrm>
-            <a:off x="3979379" y="3750316"/>
-            <a:ext cx="2346275" cy="276999"/>
-          </a:xfrm>
-          <a:prstGeom prst="rect">
-            <a:avLst/>
-          </a:prstGeom>
-          <a:noFill/>
-        </p:spPr>
-        <p:txBody>
-          <a:bodyPr wrap="square" rtlCol="0">
-            <a:spAutoFit/>
-          </a:bodyPr>
-          <a:lstStyle/>
-          <a:p>
-            <a:r>
-              <a:rPr kumimoji="1" lang="en-US" altLang="ja-JP" sz="1200" dirty="0"/>
-              <a:t>abc123</a:t>
-            </a:r>
-            <a:r>
-              <a:rPr lang="ja-JP" altLang="en-US" sz="1200" dirty="0"/>
-              <a:t>を</a:t>
-            </a:r>
-            <a:r>
-              <a:rPr lang="en-US" altLang="ja-JP" sz="1200" dirty="0" err="1"/>
-              <a:t>session_id</a:t>
-            </a:r>
-            <a:r>
-              <a:rPr lang="ja-JP" altLang="en-US" sz="1200" dirty="0"/>
-              <a:t>として検索</a:t>
-            </a:r>
-            <a:endParaRPr kumimoji="1" lang="ja-JP" altLang="en-US" sz="1200" dirty="0"/>
-          </a:p>
-        </p:txBody>
-      </p:sp>
-      <p:sp>
-        <p:nvSpPr>
-          <p:cNvPr id="15" name="フローチャート: 処理 14">
-            <a:extLst>
-              <a:ext uri="{FF2B5EF4-FFF2-40B4-BE49-F238E27FC236}">
-                <a16:creationId xmlns:a16="http://schemas.microsoft.com/office/drawing/2014/main" id="{24C863A8-358D-F219-2FD8-4EB4FCD111FD}"/>
-              </a:ext>
-            </a:extLst>
-          </p:cNvPr>
-          <p:cNvSpPr/>
-          <p:nvPr/>
-        </p:nvSpPr>
-        <p:spPr>
-          <a:xfrm>
-            <a:off x="4421458" y="4358447"/>
-            <a:ext cx="1920240" cy="814646"/>
-          </a:xfrm>
-          <a:prstGeom prst="flowChartProcess">
-            <a:avLst/>
-          </a:prstGeom>
-          <a:ln>
-            <a:noFill/>
-          </a:ln>
-        </p:spPr>
-        <p:style>
-          <a:lnRef idx="2">
-            <a:schemeClr val="accent1">
-              <a:shade val="15000"/>
-            </a:schemeClr>
-          </a:lnRef>
-          <a:fillRef idx="1">
-            <a:schemeClr val="accent1"/>
-          </a:fillRef>
-          <a:effectRef idx="0">
-            <a:schemeClr val="accent1"/>
-          </a:effectRef>
-          <a:fontRef idx="minor">
-            <a:schemeClr val="lt1"/>
-          </a:fontRef>
-        </p:style>
-        <p:txBody>
-          <a:bodyPr rtlCol="0" anchor="ctr"/>
-          <a:lstStyle/>
-          <a:p>
-            <a:pPr algn="ctr"/>
-            <a:r>
-              <a:rPr kumimoji="1" lang="ja-JP" altLang="en-US" dirty="0">
-                <a:solidFill>
-                  <a:schemeClr val="tx1">
-                    <a:lumMod val="75000"/>
-                  </a:schemeClr>
-                </a:solidFill>
-              </a:rPr>
-              <a:t>サーバ</a:t>
-            </a:r>
-            <a:r>
-              <a:rPr lang="en-US" altLang="ja-JP" dirty="0">
-                <a:solidFill>
-                  <a:schemeClr val="tx1">
-                    <a:lumMod val="75000"/>
-                  </a:schemeClr>
-                </a:solidFill>
-              </a:rPr>
-              <a:t>B</a:t>
-            </a:r>
-            <a:endParaRPr kumimoji="1" lang="en-US" altLang="ja-JP" dirty="0">
-              <a:solidFill>
-                <a:schemeClr val="tx1">
-                  <a:lumMod val="75000"/>
-                </a:schemeClr>
-              </a:solidFill>
-            </a:endParaRPr>
-          </a:p>
-        </p:txBody>
-      </p:sp>
-      <p:cxnSp>
-        <p:nvCxnSpPr>
-          <p:cNvPr id="25" name="直線矢印コネクタ 24">
-            <a:extLst>
-              <a:ext uri="{FF2B5EF4-FFF2-40B4-BE49-F238E27FC236}">
-                <a16:creationId xmlns:a16="http://schemas.microsoft.com/office/drawing/2014/main" id="{AAFC654C-13A2-0A16-E9E9-C04FE7CDA543}"/>
-              </a:ext>
-            </a:extLst>
-          </p:cNvPr>
-          <p:cNvCxnSpPr>
-            <a:cxnSpLocks/>
-            <a:endCxn id="7" idx="1"/>
-          </p:cNvCxnSpPr>
-          <p:nvPr/>
-        </p:nvCxnSpPr>
-        <p:spPr>
-          <a:xfrm flipV="1">
-            <a:off x="1299094" y="2879724"/>
-            <a:ext cx="3122364" cy="1052627"/>
-          </a:xfrm>
-          <a:prstGeom prst="straightConnector1">
-            <a:avLst/>
-          </a:prstGeom>
-          <a:ln w="44450">
-            <a:tailEnd type="triangle"/>
-          </a:ln>
-        </p:spPr>
-        <p:style>
-          <a:lnRef idx="2">
-            <a:schemeClr val="accent1"/>
-          </a:lnRef>
-          <a:fillRef idx="0">
-            <a:schemeClr val="accent1"/>
-          </a:fillRef>
-          <a:effectRef idx="1">
-            <a:schemeClr val="accent1"/>
-          </a:effectRef>
-          <a:fontRef idx="minor">
-            <a:schemeClr val="tx1"/>
-          </a:fontRef>
-        </p:style>
-      </p:cxnSp>
-      <p:sp>
-        <p:nvSpPr>
-          <p:cNvPr id="14" name="テキスト ボックス 13">
-            <a:extLst>
-              <a:ext uri="{FF2B5EF4-FFF2-40B4-BE49-F238E27FC236}">
-                <a16:creationId xmlns:a16="http://schemas.microsoft.com/office/drawing/2014/main" id="{EE1A979A-D9EF-1A6C-DE3E-34856F25B295}"/>
-              </a:ext>
-            </a:extLst>
-          </p:cNvPr>
-          <p:cNvSpPr txBox="1"/>
-          <p:nvPr/>
-        </p:nvSpPr>
-        <p:spPr>
-          <a:xfrm>
-            <a:off x="1323255" y="3326472"/>
-            <a:ext cx="2191687" cy="830997"/>
-          </a:xfrm>
-          <a:prstGeom prst="rect">
-            <a:avLst/>
-          </a:prstGeom>
-          <a:noFill/>
-        </p:spPr>
-        <p:txBody>
-          <a:bodyPr wrap="square" rtlCol="0">
-            <a:spAutoFit/>
-          </a:bodyPr>
-          <a:lstStyle/>
-          <a:p>
-            <a:r>
-              <a:rPr kumimoji="1" lang="en-US" altLang="ja-JP" sz="1200" dirty="0"/>
-              <a:t>GET /</a:t>
-            </a:r>
-            <a:r>
-              <a:rPr kumimoji="1" lang="en-US" altLang="ja-JP" sz="1200" dirty="0" err="1"/>
-              <a:t>mypage</a:t>
-            </a:r>
-            <a:endParaRPr kumimoji="1" lang="en-US" altLang="ja-JP" sz="1200" dirty="0"/>
-          </a:p>
-          <a:p>
-            <a:r>
-              <a:rPr lang="en-US" altLang="ja-JP" sz="1200" b="1" dirty="0"/>
-              <a:t>Cookie:</a:t>
-            </a:r>
-          </a:p>
-          <a:p>
-            <a:r>
-              <a:rPr kumimoji="1" lang="en-US" altLang="ja-JP" sz="1200" b="1" dirty="0" err="1"/>
-              <a:t>Session_id</a:t>
-            </a:r>
-            <a:r>
-              <a:rPr kumimoji="1" lang="en-US" altLang="ja-JP" sz="1200" b="1" dirty="0"/>
-              <a:t>=abc123</a:t>
-            </a:r>
-          </a:p>
-          <a:p>
-            <a:endParaRPr kumimoji="1" lang="ja-JP" altLang="en-US" sz="1200" dirty="0"/>
-          </a:p>
-        </p:txBody>
-      </p:sp>
-      <p:cxnSp>
-        <p:nvCxnSpPr>
-          <p:cNvPr id="28" name="直線矢印コネクタ 27">
-            <a:extLst>
-              <a:ext uri="{FF2B5EF4-FFF2-40B4-BE49-F238E27FC236}">
-                <a16:creationId xmlns:a16="http://schemas.microsoft.com/office/drawing/2014/main" id="{CEA932BB-52DE-3AD7-5D56-283FF5BCC42F}"/>
-              </a:ext>
-            </a:extLst>
-          </p:cNvPr>
-          <p:cNvCxnSpPr>
-            <a:cxnSpLocks/>
-            <a:stCxn id="15" idx="3"/>
-          </p:cNvCxnSpPr>
-          <p:nvPr/>
-        </p:nvCxnSpPr>
-        <p:spPr>
-          <a:xfrm flipV="1">
-            <a:off x="6341698" y="4292288"/>
-            <a:ext cx="1920240" cy="473482"/>
-          </a:xfrm>
-          <a:prstGeom prst="straightConnector1">
-            <a:avLst/>
-          </a:prstGeom>
-          <a:ln w="44450">
-            <a:tailEnd type="triangle"/>
-          </a:ln>
-        </p:spPr>
-        <p:style>
-          <a:lnRef idx="2">
-            <a:schemeClr val="accent1"/>
-          </a:lnRef>
-          <a:fillRef idx="0">
-            <a:schemeClr val="accent1"/>
-          </a:fillRef>
-          <a:effectRef idx="1">
-            <a:schemeClr val="accent1"/>
-          </a:effectRef>
-          <a:fontRef idx="minor">
-            <a:schemeClr val="tx1"/>
-          </a:fontRef>
-        </p:style>
-      </p:cxnSp>
-      <p:cxnSp>
-        <p:nvCxnSpPr>
-          <p:cNvPr id="31" name="直線矢印コネクタ 30">
-            <a:extLst>
-              <a:ext uri="{FF2B5EF4-FFF2-40B4-BE49-F238E27FC236}">
-                <a16:creationId xmlns:a16="http://schemas.microsoft.com/office/drawing/2014/main" id="{ED0E1DF1-94B6-4E48-6D5A-95A613F74768}"/>
-              </a:ext>
-            </a:extLst>
-          </p:cNvPr>
-          <p:cNvCxnSpPr>
-            <a:cxnSpLocks/>
-            <a:stCxn id="7" idx="3"/>
-          </p:cNvCxnSpPr>
-          <p:nvPr/>
-        </p:nvCxnSpPr>
-        <p:spPr>
-          <a:xfrm>
-            <a:off x="6341698" y="2879724"/>
-            <a:ext cx="1920240" cy="1260541"/>
-          </a:xfrm>
-          <a:prstGeom prst="straightConnector1">
-            <a:avLst/>
-          </a:prstGeom>
-          <a:ln w="44450">
-            <a:tailEnd type="triangle"/>
-          </a:ln>
-        </p:spPr>
-        <p:style>
-          <a:lnRef idx="2">
-            <a:schemeClr val="accent1"/>
-          </a:lnRef>
-          <a:fillRef idx="0">
-            <a:schemeClr val="accent1"/>
-          </a:fillRef>
-          <a:effectRef idx="1">
-            <a:schemeClr val="accent1"/>
-          </a:effectRef>
-          <a:fontRef idx="minor">
-            <a:schemeClr val="tx1"/>
-          </a:fontRef>
-        </p:style>
-      </p:cxnSp>
-    </p:spTree>
-    <p:extLst>
-      <p:ext uri="{BB962C8B-B14F-4D97-AF65-F5344CB8AC3E}">
-        <p14:creationId xmlns:p14="http://schemas.microsoft.com/office/powerpoint/2010/main" val="3014831916"/>
-      </p:ext>
-    </p:extLst>
-  </p:cSld>
-  <p:clrMapOvr>
-    <a:masterClrMapping/>
-  </p:clrMapOvr>
-</p:sld>
-</file>
-
-<file path=ppt/slides/slide11.xml><?xml version="1.0" encoding="utf-8"?>
-<p:sld xmlns:a="http://schemas.openxmlformats.org/drawingml/2006/main" xmlns:r="http://schemas.openxmlformats.org/officeDocument/2006/relationships" xmlns:p="http://schemas.openxmlformats.org/presentationml/2006/main">
-  <p:cSld>
-    <p:spTree>
-      <p:nvGrpSpPr>
-        <p:cNvPr id="1" name="">
-          <a:extLst>
-            <a:ext uri="{FF2B5EF4-FFF2-40B4-BE49-F238E27FC236}">
               <a16:creationId xmlns:a16="http://schemas.microsoft.com/office/drawing/2014/main" id="{618DE28A-372F-1D12-7E20-3F13964FA2A1}"/>
             </a:ext>
           </a:extLst>
@@ -7199,7 +5586,7 @@
 </p:sld>
 </file>
 
-<file path=ppt/slides/slide12.xml><?xml version="1.0" encoding="utf-8"?>
+<file path=ppt/slides/slide11.xml><?xml version="1.0" encoding="utf-8"?>
 <p:sld xmlns:a="http://schemas.openxmlformats.org/drawingml/2006/main" xmlns:r="http://schemas.openxmlformats.org/officeDocument/2006/relationships" xmlns:p="http://schemas.openxmlformats.org/presentationml/2006/main">
   <p:cSld>
     <p:spTree>
@@ -7276,7 +5663,7 @@
 </p:sld>
 </file>
 
-<file path=ppt/slides/slide13.xml><?xml version="1.0" encoding="utf-8"?>
+<file path=ppt/slides/slide12.xml><?xml version="1.0" encoding="utf-8"?>
 <p:sld xmlns:a="http://schemas.openxmlformats.org/drawingml/2006/main" xmlns:r="http://schemas.openxmlformats.org/officeDocument/2006/relationships" xmlns:p="http://schemas.openxmlformats.org/presentationml/2006/main">
   <p:cSld>
     <p:spTree>
@@ -14091,7 +12478,7 @@
           <p:nvPr>
             <p:extLst>
               <p:ext uri="{D42A27DB-BD31-4B8C-83A1-F6EECF244321}">
-                <p14:modId xmlns:p14="http://schemas.microsoft.com/office/powerpoint/2010/main" val="2176495478"/>
+                <p14:modId xmlns:p14="http://schemas.microsoft.com/office/powerpoint/2010/main" val="4155481401"/>
               </p:ext>
             </p:extLst>
           </p:nvPr>
@@ -16278,7 +14665,7 @@
         <p:cNvPr id="1" name="">
           <a:extLst>
             <a:ext uri="{FF2B5EF4-FFF2-40B4-BE49-F238E27FC236}">
-              <a16:creationId xmlns:a16="http://schemas.microsoft.com/office/drawing/2014/main" id="{2F00A0ED-E456-D3A0-A6CE-4478C9B20D53}"/>
+              <a16:creationId xmlns:a16="http://schemas.microsoft.com/office/drawing/2014/main" id="{F4C1BDB2-5649-A327-2B01-93BF748FEFD9}"/>
             </a:ext>
           </a:extLst>
         </p:cNvPr>
@@ -16298,7 +14685,7 @@
           <p:cNvPr id="2" name="直線コネクタ 1">
             <a:extLst>
               <a:ext uri="{FF2B5EF4-FFF2-40B4-BE49-F238E27FC236}">
-                <a16:creationId xmlns:a16="http://schemas.microsoft.com/office/drawing/2014/main" id="{9C6AC353-79A4-025D-2407-6DB089781B84}"/>
+                <a16:creationId xmlns:a16="http://schemas.microsoft.com/office/drawing/2014/main" id="{A1B8D59F-005F-C25E-624C-282771D1CBF8}"/>
               </a:ext>
             </a:extLst>
           </p:cNvPr>
@@ -16337,7 +14724,7 @@
           <p:cNvPr id="3" name="タイトル プレースホルダー 1">
             <a:extLst>
               <a:ext uri="{FF2B5EF4-FFF2-40B4-BE49-F238E27FC236}">
-                <a16:creationId xmlns:a16="http://schemas.microsoft.com/office/drawing/2014/main" id="{5FB7B477-52FD-0FD2-95CB-29980E1FF5DA}"/>
+                <a16:creationId xmlns:a16="http://schemas.microsoft.com/office/drawing/2014/main" id="{02B030B6-2F82-3D76-693F-FF8F6A794BDA}"/>
               </a:ext>
             </a:extLst>
           </p:cNvPr>
@@ -16381,15 +14768,15 @@
           <a:p>
             <a:r>
               <a:rPr lang="ja-JP" altLang="en-US" sz="2800" dirty="0"/>
-              <a:t>ログイン後の処理として、ブラウザは保存した</a:t>
+              <a:t>共有のセッションストアで、セッション</a:t>
             </a:r>
             <a:r>
               <a:rPr lang="en-US" altLang="ja-JP" sz="2800" dirty="0"/>
-              <a:t>Cookie</a:t>
+              <a:t>ID</a:t>
             </a:r>
             <a:r>
               <a:rPr lang="ja-JP" altLang="en-US" sz="2800" dirty="0"/>
-              <a:t>を対象のサーバへ次のリクエストでも送る。これにより、リクエストがどのユーザからのものかを認証する。</a:t>
+              <a:t>による管理をすれば、異なるサーバにアクセスしたとしても目的の情報が返ってくる。</a:t>
             </a:r>
             <a:endParaRPr lang="en-US" altLang="ja-JP" sz="2800" dirty="0"/>
           </a:p>
@@ -16400,7 +14787,7 @@
           <p:cNvPr id="4" name="タイトル プレースホルダー 1">
             <a:extLst>
               <a:ext uri="{FF2B5EF4-FFF2-40B4-BE49-F238E27FC236}">
-                <a16:creationId xmlns:a16="http://schemas.microsoft.com/office/drawing/2014/main" id="{4F50868B-7BE8-38C5-65A4-4B4E106F3F09}"/>
+                <a16:creationId xmlns:a16="http://schemas.microsoft.com/office/drawing/2014/main" id="{3E8F089A-9AB5-5730-0321-D3BD2781FF59}"/>
               </a:ext>
             </a:extLst>
           </p:cNvPr>
@@ -16455,7 +14842,7 @@
           <p:cNvPr id="6" name="フローチャート: 処理 5">
             <a:extLst>
               <a:ext uri="{FF2B5EF4-FFF2-40B4-BE49-F238E27FC236}">
-                <a16:creationId xmlns:a16="http://schemas.microsoft.com/office/drawing/2014/main" id="{CF79A311-9903-C3B6-AC99-67BBD1AC5F4D}"/>
+                <a16:creationId xmlns:a16="http://schemas.microsoft.com/office/drawing/2014/main" id="{2D3CB13F-835E-0809-45B5-763CB46C87F4}"/>
               </a:ext>
             </a:extLst>
           </p:cNvPr>
@@ -16560,7 +14947,7 @@
           <p:cNvPr id="7" name="フローチャート: 処理 6">
             <a:extLst>
               <a:ext uri="{FF2B5EF4-FFF2-40B4-BE49-F238E27FC236}">
-                <a16:creationId xmlns:a16="http://schemas.microsoft.com/office/drawing/2014/main" id="{71308D4D-0E17-A843-BF96-F7AD0ABA95E9}"/>
+                <a16:creationId xmlns:a16="http://schemas.microsoft.com/office/drawing/2014/main" id="{0FB4BC16-C126-6F78-EBC6-92C145832CD3}"/>
               </a:ext>
             </a:extLst>
           </p:cNvPr>
@@ -16610,6 +14997,16 @@
               </a:rPr>
               <a:t>サーバ</a:t>
             </a:r>
+            <a:r>
+              <a:rPr kumimoji="1" lang="en-US" altLang="ja-JP" dirty="0">
+                <a:solidFill>
+                  <a:schemeClr val="tx1">
+                    <a:lumMod val="75000"/>
+                  </a:schemeClr>
+                </a:solidFill>
+              </a:rPr>
+              <a:t>A</a:t>
+            </a:r>
           </a:p>
         </p:txBody>
       </p:sp>
@@ -16618,7 +15015,7 @@
           <p:cNvPr id="8" name="直線コネクタ 7">
             <a:extLst>
               <a:ext uri="{FF2B5EF4-FFF2-40B4-BE49-F238E27FC236}">
-                <a16:creationId xmlns:a16="http://schemas.microsoft.com/office/drawing/2014/main" id="{DE1ADE6A-2250-EE80-B7C5-8D44C5DE4E63}"/>
+                <a16:creationId xmlns:a16="http://schemas.microsoft.com/office/drawing/2014/main" id="{A6DDCE87-042B-E6D0-2658-B5A01D45C85B}"/>
               </a:ext>
             </a:extLst>
           </p:cNvPr>
@@ -16656,7 +15053,7 @@
           <p:cNvPr id="9" name="直線コネクタ 8">
             <a:extLst>
               <a:ext uri="{FF2B5EF4-FFF2-40B4-BE49-F238E27FC236}">
-                <a16:creationId xmlns:a16="http://schemas.microsoft.com/office/drawing/2014/main" id="{89999DE5-0936-FE1B-21D9-D0AAB2FC6C57}"/>
+                <a16:creationId xmlns:a16="http://schemas.microsoft.com/office/drawing/2014/main" id="{479B5EC8-48E1-93E3-0E3A-F5ACE8FA021A}"/>
               </a:ext>
             </a:extLst>
           </p:cNvPr>
@@ -16694,7 +15091,49 @@
           <p:cNvPr id="10" name="直線矢印コネクタ 9">
             <a:extLst>
               <a:ext uri="{FF2B5EF4-FFF2-40B4-BE49-F238E27FC236}">
-                <a16:creationId xmlns:a16="http://schemas.microsoft.com/office/drawing/2014/main" id="{D33A8F10-70DD-7614-43E6-87DD7C1ED1F7}"/>
+                <a16:creationId xmlns:a16="http://schemas.microsoft.com/office/drawing/2014/main" id="{13CD9B52-4D27-9218-98BD-560392B30835}"/>
+              </a:ext>
+            </a:extLst>
+          </p:cNvPr>
+          <p:cNvCxnSpPr>
+            <a:cxnSpLocks/>
+            <a:endCxn id="15" idx="1"/>
+          </p:cNvCxnSpPr>
+          <p:nvPr/>
+        </p:nvCxnSpPr>
+        <p:spPr>
+          <a:xfrm>
+            <a:off x="1315720" y="3923369"/>
+            <a:ext cx="3105738" cy="842401"/>
+          </a:xfrm>
+          <a:prstGeom prst="straightConnector1">
+            <a:avLst/>
+          </a:prstGeom>
+          <a:ln w="44450">
+            <a:tailEnd type="triangle"/>
+          </a:ln>
+        </p:spPr>
+        <p:style>
+          <a:lnRef idx="2">
+            <a:schemeClr val="accent1"/>
+          </a:lnRef>
+          <a:fillRef idx="0">
+            <a:schemeClr val="accent1"/>
+          </a:fillRef>
+          <a:effectRef idx="1">
+            <a:schemeClr val="accent1"/>
+          </a:effectRef>
+          <a:fontRef idx="minor">
+            <a:schemeClr val="tx1"/>
+          </a:fontRef>
+        </p:style>
+      </p:cxnSp>
+      <p:cxnSp>
+        <p:nvCxnSpPr>
+          <p:cNvPr id="11" name="直線矢印コネクタ 10">
+            <a:extLst>
+              <a:ext uri="{FF2B5EF4-FFF2-40B4-BE49-F238E27FC236}">
+                <a16:creationId xmlns:a16="http://schemas.microsoft.com/office/drawing/2014/main" id="{FB276DBC-CCA3-20EB-205E-D2CAF72440B5}"/>
               </a:ext>
             </a:extLst>
           </p:cNvPr>
@@ -16704,8 +15143,8 @@
           <p:nvPr/>
         </p:nvCxnSpPr>
         <p:spPr>
-          <a:xfrm>
-            <a:off x="1315720" y="3923369"/>
+          <a:xfrm flipH="1">
+            <a:off x="1315720" y="6236879"/>
             <a:ext cx="4097064" cy="0"/>
           </a:xfrm>
           <a:prstGeom prst="straightConnector1">
@@ -16730,53 +15169,12 @@
           </a:fontRef>
         </p:style>
       </p:cxnSp>
-      <p:cxnSp>
-        <p:nvCxnSpPr>
-          <p:cNvPr id="11" name="直線矢印コネクタ 10">
-            <a:extLst>
-              <a:ext uri="{FF2B5EF4-FFF2-40B4-BE49-F238E27FC236}">
-                <a16:creationId xmlns:a16="http://schemas.microsoft.com/office/drawing/2014/main" id="{B840D738-2C75-E065-4466-E977A3FE9A0D}"/>
-              </a:ext>
-            </a:extLst>
-          </p:cNvPr>
-          <p:cNvCxnSpPr>
-            <a:cxnSpLocks/>
-          </p:cNvCxnSpPr>
-          <p:nvPr/>
-        </p:nvCxnSpPr>
-        <p:spPr>
-          <a:xfrm flipH="1">
-            <a:off x="1315720" y="5854491"/>
-            <a:ext cx="4097064" cy="0"/>
-          </a:xfrm>
-          <a:prstGeom prst="straightConnector1">
-            <a:avLst/>
-          </a:prstGeom>
-          <a:ln w="44450">
-            <a:tailEnd type="triangle"/>
-          </a:ln>
-        </p:spPr>
-        <p:style>
-          <a:lnRef idx="2">
-            <a:schemeClr val="accent1"/>
-          </a:lnRef>
-          <a:fillRef idx="0">
-            <a:schemeClr val="accent1"/>
-          </a:fillRef>
-          <a:effectRef idx="1">
-            <a:schemeClr val="accent1"/>
-          </a:effectRef>
-          <a:fontRef idx="minor">
-            <a:schemeClr val="tx1"/>
-          </a:fontRef>
-        </p:style>
-      </p:cxnSp>
       <p:sp>
         <p:nvSpPr>
           <p:cNvPr id="12" name="フローチャート: 処理 11">
             <a:extLst>
               <a:ext uri="{FF2B5EF4-FFF2-40B4-BE49-F238E27FC236}">
-                <a16:creationId xmlns:a16="http://schemas.microsoft.com/office/drawing/2014/main" id="{DC19F33E-6E1F-D152-C02A-6374ED057D5B}"/>
+                <a16:creationId xmlns:a16="http://schemas.microsoft.com/office/drawing/2014/main" id="{18944945-24C9-90FA-0529-7B602F9F36FF}"/>
               </a:ext>
             </a:extLst>
           </p:cNvPr>
@@ -16834,7 +15232,7 @@
           <p:cNvPr id="13" name="直線コネクタ 12">
             <a:extLst>
               <a:ext uri="{FF2B5EF4-FFF2-40B4-BE49-F238E27FC236}">
-                <a16:creationId xmlns:a16="http://schemas.microsoft.com/office/drawing/2014/main" id="{68905582-B03E-9803-D24A-DEF1374A100A}"/>
+                <a16:creationId xmlns:a16="http://schemas.microsoft.com/office/drawing/2014/main" id="{2853CB51-9733-80B0-28D0-429DD3DA70B9}"/>
               </a:ext>
             </a:extLst>
           </p:cNvPr>
@@ -16867,71 +15265,12 @@
           </a:fontRef>
         </p:style>
       </p:cxnSp>
-      <p:sp>
-        <p:nvSpPr>
-          <p:cNvPr id="14" name="テキスト ボックス 13">
-            <a:extLst>
-              <a:ext uri="{FF2B5EF4-FFF2-40B4-BE49-F238E27FC236}">
-                <a16:creationId xmlns:a16="http://schemas.microsoft.com/office/drawing/2014/main" id="{D3C121B4-B2D8-04C2-F6E5-F8183E6C1B8D}"/>
-              </a:ext>
-            </a:extLst>
-          </p:cNvPr>
-          <p:cNvSpPr txBox="1"/>
-          <p:nvPr/>
-        </p:nvSpPr>
-        <p:spPr>
-          <a:xfrm>
-            <a:off x="1323255" y="3326472"/>
-            <a:ext cx="2191687" cy="830997"/>
-          </a:xfrm>
-          <a:prstGeom prst="rect">
-            <a:avLst/>
-          </a:prstGeom>
-          <a:noFill/>
-        </p:spPr>
-        <p:txBody>
-          <a:bodyPr wrap="square" rtlCol="0">
-            <a:spAutoFit/>
-          </a:bodyPr>
-          <a:lstStyle/>
-          <a:p>
-            <a:r>
-              <a:rPr kumimoji="1" lang="en-US" altLang="ja-JP" sz="1200" dirty="0"/>
-              <a:t>GET /</a:t>
-            </a:r>
-            <a:r>
-              <a:rPr kumimoji="1" lang="en-US" altLang="ja-JP" sz="1200" dirty="0" err="1"/>
-              <a:t>mypage</a:t>
-            </a:r>
-            <a:endParaRPr kumimoji="1" lang="en-US" altLang="ja-JP" sz="1200" dirty="0"/>
-          </a:p>
-          <a:p>
-            <a:r>
-              <a:rPr lang="en-US" altLang="ja-JP" sz="1200" b="1" dirty="0"/>
-              <a:t>Cookie:</a:t>
-            </a:r>
-          </a:p>
-          <a:p>
-            <a:r>
-              <a:rPr kumimoji="1" lang="en-US" altLang="ja-JP" sz="1200" b="1" dirty="0" err="1"/>
-              <a:t>Session_id</a:t>
-            </a:r>
-            <a:r>
-              <a:rPr kumimoji="1" lang="en-US" altLang="ja-JP" sz="1200" b="1" dirty="0"/>
-              <a:t>=abc123</a:t>
-            </a:r>
-          </a:p>
-          <a:p>
-            <a:endParaRPr kumimoji="1" lang="ja-JP" altLang="en-US" sz="1200" dirty="0"/>
-          </a:p>
-        </p:txBody>
-      </p:sp>
       <p:cxnSp>
         <p:nvCxnSpPr>
           <p:cNvPr id="16" name="直線矢印コネクタ 15">
             <a:extLst>
               <a:ext uri="{FF2B5EF4-FFF2-40B4-BE49-F238E27FC236}">
-                <a16:creationId xmlns:a16="http://schemas.microsoft.com/office/drawing/2014/main" id="{6C3B8097-D445-BD79-F2F7-7079B5D0A5CF}"/>
+                <a16:creationId xmlns:a16="http://schemas.microsoft.com/office/drawing/2014/main" id="{8376B734-BE36-355B-3240-CA9B93472A13}"/>
               </a:ext>
             </a:extLst>
           </p:cNvPr>
@@ -16942,7 +15281,7 @@
         </p:nvCxnSpPr>
         <p:spPr>
           <a:xfrm>
-            <a:off x="5372323" y="4879331"/>
+            <a:off x="5372323" y="5685666"/>
             <a:ext cx="2905218" cy="0"/>
           </a:xfrm>
           <a:prstGeom prst="straightConnector1">
@@ -16972,7 +15311,7 @@
           <p:cNvPr id="17" name="テキスト ボックス 16">
             <a:extLst>
               <a:ext uri="{FF2B5EF4-FFF2-40B4-BE49-F238E27FC236}">
-                <a16:creationId xmlns:a16="http://schemas.microsoft.com/office/drawing/2014/main" id="{CBADAD40-41BF-0516-E9CD-23F7458D6188}"/>
+                <a16:creationId xmlns:a16="http://schemas.microsoft.com/office/drawing/2014/main" id="{1BF24439-8ED8-CF3D-5BE2-D0F31C72E601}"/>
               </a:ext>
             </a:extLst>
           </p:cNvPr>
@@ -16981,7 +15320,7 @@
         </p:nvSpPr>
         <p:spPr>
           <a:xfrm>
-            <a:off x="5372323" y="4574622"/>
+            <a:off x="5372323" y="5380957"/>
             <a:ext cx="2346275" cy="276999"/>
           </a:xfrm>
           <a:prstGeom prst="rect">
@@ -17020,7 +15359,7 @@
           <p:cNvPr id="18" name="表 17">
             <a:extLst>
               <a:ext uri="{FF2B5EF4-FFF2-40B4-BE49-F238E27FC236}">
-                <a16:creationId xmlns:a16="http://schemas.microsoft.com/office/drawing/2014/main" id="{408B52C9-E92C-B96F-3A28-C9E416348C89}"/>
+                <a16:creationId xmlns:a16="http://schemas.microsoft.com/office/drawing/2014/main" id="{03697418-9D28-4A6D-F79F-ED39A714B6CD}"/>
               </a:ext>
             </a:extLst>
           </p:cNvPr>
@@ -17387,125 +15726,10 @@
       </p:graphicFrame>
       <p:sp>
         <p:nvSpPr>
-          <p:cNvPr id="19" name="吹き出し: 円形 18">
-            <a:extLst>
-              <a:ext uri="{FF2B5EF4-FFF2-40B4-BE49-F238E27FC236}">
-                <a16:creationId xmlns:a16="http://schemas.microsoft.com/office/drawing/2014/main" id="{6A1C803E-0FF5-2161-5197-C06CB7AF1915}"/>
-              </a:ext>
-            </a:extLst>
-          </p:cNvPr>
-          <p:cNvSpPr/>
-          <p:nvPr/>
-        </p:nvSpPr>
-        <p:spPr>
-          <a:xfrm>
-            <a:off x="9755260" y="3228736"/>
-            <a:ext cx="2081140" cy="925335"/>
-          </a:xfrm>
-          <a:prstGeom prst="wedgeEllipseCallout">
-            <a:avLst/>
-          </a:prstGeom>
-        </p:spPr>
-        <p:style>
-          <a:lnRef idx="2">
-            <a:schemeClr val="accent1">
-              <a:shade val="15000"/>
-            </a:schemeClr>
-          </a:lnRef>
-          <a:fillRef idx="1">
-            <a:schemeClr val="accent1"/>
-          </a:fillRef>
-          <a:effectRef idx="0">
-            <a:schemeClr val="accent1"/>
-          </a:effectRef>
-          <a:fontRef idx="minor">
-            <a:schemeClr val="lt1"/>
-          </a:fontRef>
-        </p:style>
-        <p:txBody>
-          <a:bodyPr rtlCol="0" anchor="ctr"/>
-          <a:lstStyle/>
-          <a:p>
-            <a:pPr algn="ctr"/>
-            <a:r>
-              <a:rPr kumimoji="1" lang="ja-JP" altLang="en-US" sz="1400" dirty="0">
-                <a:solidFill>
-                  <a:schemeClr val="tx1">
-                    <a:lumMod val="75000"/>
-                  </a:schemeClr>
-                </a:solidFill>
-              </a:rPr>
-              <a:t>セッションストアで</a:t>
-            </a:r>
-            <a:r>
-              <a:rPr kumimoji="1" lang="en-US" altLang="ja-JP" sz="1400" dirty="0" err="1">
-                <a:solidFill>
-                  <a:schemeClr val="tx1">
-                    <a:lumMod val="75000"/>
-                  </a:schemeClr>
-                </a:solidFill>
-              </a:rPr>
-              <a:t>User_ID</a:t>
-            </a:r>
-            <a:r>
-              <a:rPr kumimoji="1" lang="ja-JP" altLang="en-US" sz="1400" dirty="0">
-                <a:solidFill>
-                  <a:schemeClr val="tx1">
-                    <a:lumMod val="75000"/>
-                  </a:schemeClr>
-                </a:solidFill>
-              </a:rPr>
-              <a:t>と</a:t>
-            </a:r>
-            <a:r>
-              <a:rPr kumimoji="1" lang="en-US" altLang="ja-JP" sz="1400" dirty="0" err="1">
-                <a:solidFill>
-                  <a:schemeClr val="tx1">
-                    <a:lumMod val="75000"/>
-                  </a:schemeClr>
-                </a:solidFill>
-              </a:rPr>
-              <a:t>session_id</a:t>
-            </a:r>
-            <a:r>
-              <a:rPr kumimoji="1" lang="ja-JP" altLang="en-US" sz="1400" dirty="0">
-                <a:solidFill>
-                  <a:schemeClr val="tx1">
-                    <a:lumMod val="75000"/>
-                  </a:schemeClr>
-                </a:solidFill>
-              </a:rPr>
-              <a:t>の</a:t>
-            </a:r>
-            <a:endParaRPr kumimoji="1" lang="en-US" altLang="ja-JP" sz="1400" dirty="0">
-              <a:solidFill>
-                <a:schemeClr val="tx1">
-                  <a:lumMod val="75000"/>
-                </a:schemeClr>
-              </a:solidFill>
-            </a:endParaRPr>
-          </a:p>
-          <a:p>
-            <a:pPr algn="ctr"/>
-            <a:r>
-              <a:rPr kumimoji="1" lang="ja-JP" altLang="en-US" sz="1400" dirty="0">
-                <a:solidFill>
-                  <a:schemeClr val="tx1">
-                    <a:lumMod val="75000"/>
-                  </a:schemeClr>
-                </a:solidFill>
-              </a:rPr>
-              <a:t>組合せを保持</a:t>
-            </a:r>
-          </a:p>
-        </p:txBody>
-      </p:sp>
-      <p:sp>
-        <p:nvSpPr>
           <p:cNvPr id="20" name="テキスト ボックス 19">
             <a:extLst>
               <a:ext uri="{FF2B5EF4-FFF2-40B4-BE49-F238E27FC236}">
-                <a16:creationId xmlns:a16="http://schemas.microsoft.com/office/drawing/2014/main" id="{46C5EF62-C199-F856-8C22-C96A74577942}"/>
+                <a16:creationId xmlns:a16="http://schemas.microsoft.com/office/drawing/2014/main" id="{5ABF4178-710C-51DA-95DF-25E1AE10FB25}"/>
               </a:ext>
             </a:extLst>
           </p:cNvPr>
@@ -17514,7 +15738,7 @@
         </p:nvSpPr>
         <p:spPr>
           <a:xfrm>
-            <a:off x="3235070" y="5420753"/>
+            <a:off x="3235070" y="6227088"/>
             <a:ext cx="2191687" cy="461665"/>
           </a:xfrm>
           <a:prstGeom prst="rect">
@@ -17554,7 +15778,7 @@
           <p:cNvPr id="21" name="吹き出し: 円形 20">
             <a:extLst>
               <a:ext uri="{FF2B5EF4-FFF2-40B4-BE49-F238E27FC236}">
-                <a16:creationId xmlns:a16="http://schemas.microsoft.com/office/drawing/2014/main" id="{12AD58C4-71C5-123E-1B4D-EE0A48C0AF83}"/>
+                <a16:creationId xmlns:a16="http://schemas.microsoft.com/office/drawing/2014/main" id="{727CDF50-827C-F8DA-EA8B-885466EE2D50}"/>
               </a:ext>
             </a:extLst>
           </p:cNvPr>
@@ -17563,13 +15787,13 @@
         </p:nvSpPr>
         <p:spPr>
           <a:xfrm>
-            <a:off x="1807077" y="4025915"/>
+            <a:off x="1540537" y="4514986"/>
             <a:ext cx="2337581" cy="925335"/>
           </a:xfrm>
           <a:prstGeom prst="wedgeEllipseCallout">
             <a:avLst>
-              <a:gd name="adj1" fmla="val -65170"/>
-              <a:gd name="adj2" fmla="val -51590"/>
+              <a:gd name="adj1" fmla="val -33165"/>
+              <a:gd name="adj2" fmla="val -85727"/>
             </a:avLst>
           </a:prstGeom>
         </p:spPr>
@@ -17602,27 +15826,7 @@
                   </a:schemeClr>
                 </a:solidFill>
               </a:rPr>
-              <a:t>あ、私</a:t>
-            </a:r>
-            <a:r>
-              <a:rPr kumimoji="1" lang="en-US" altLang="ja-JP" sz="1400" dirty="0">
-                <a:solidFill>
-                  <a:schemeClr val="tx1">
-                    <a:lumMod val="75000"/>
-                  </a:schemeClr>
-                </a:solidFill>
-              </a:rPr>
-              <a:t>(hiroki01)</a:t>
-            </a:r>
-            <a:r>
-              <a:rPr kumimoji="1" lang="ja-JP" altLang="en-US" sz="1400" dirty="0">
-                <a:solidFill>
-                  <a:schemeClr val="tx1">
-                    <a:lumMod val="75000"/>
-                  </a:schemeClr>
-                </a:solidFill>
-              </a:rPr>
-              <a:t>はセッションとしてこれを使ったらいいのね</a:t>
+              <a:t>どちらにアクセスしても同じ結果が</a:t>
             </a:r>
             <a:endParaRPr kumimoji="1" lang="en-US" altLang="ja-JP" sz="1400" dirty="0">
               <a:solidFill>
@@ -17635,42 +15839,15 @@
           <a:p>
             <a:pPr algn="ctr"/>
             <a:r>
-              <a:rPr lang="ja-JP" altLang="en-US" sz="1400" dirty="0">
+              <a:rPr kumimoji="1" lang="ja-JP" altLang="en-US" sz="1400" dirty="0">
                 <a:solidFill>
                   <a:schemeClr val="tx1">
                     <a:lumMod val="75000"/>
                   </a:schemeClr>
                 </a:solidFill>
               </a:rPr>
-              <a:t>「</a:t>
-            </a:r>
-            <a:r>
-              <a:rPr lang="en-US" altLang="ja-JP" sz="1400" dirty="0">
-                <a:solidFill>
-                  <a:schemeClr val="tx1">
-                    <a:lumMod val="75000"/>
-                  </a:schemeClr>
-                </a:solidFill>
-              </a:rPr>
-              <a:t>abc123</a:t>
-            </a:r>
-            <a:r>
-              <a:rPr lang="ja-JP" altLang="en-US" sz="1400" dirty="0">
-                <a:solidFill>
-                  <a:schemeClr val="tx1">
-                    <a:lumMod val="75000"/>
-                  </a:schemeClr>
-                </a:solidFill>
-              </a:rPr>
-              <a:t>」</a:t>
-            </a:r>
-            <a:endParaRPr kumimoji="1" lang="ja-JP" altLang="en-US" sz="1400" dirty="0">
-              <a:solidFill>
-                <a:schemeClr val="tx1">
-                  <a:lumMod val="75000"/>
-                </a:schemeClr>
-              </a:solidFill>
-            </a:endParaRPr>
+              <a:t>返ってくる！</a:t>
+            </a:r>
           </a:p>
         </p:txBody>
       </p:sp>
@@ -17679,7 +15856,7 @@
           <p:cNvPr id="22" name="直線矢印コネクタ 21">
             <a:extLst>
               <a:ext uri="{FF2B5EF4-FFF2-40B4-BE49-F238E27FC236}">
-                <a16:creationId xmlns:a16="http://schemas.microsoft.com/office/drawing/2014/main" id="{A6C0FC38-63E6-0D84-9F39-EB1ACC6FED95}"/>
+                <a16:creationId xmlns:a16="http://schemas.microsoft.com/office/drawing/2014/main" id="{A137211D-22A6-9107-F8EC-F641481C2453}"/>
               </a:ext>
             </a:extLst>
           </p:cNvPr>
@@ -17690,7 +15867,7 @@
         </p:nvCxnSpPr>
         <p:spPr>
           <a:xfrm flipH="1">
-            <a:off x="5381578" y="5239349"/>
+            <a:off x="5381578" y="6045684"/>
             <a:ext cx="2880360" cy="0"/>
           </a:xfrm>
           <a:prstGeom prst="straightConnector1">
@@ -17720,7 +15897,7 @@
           <p:cNvPr id="24" name="テキスト ボックス 23">
             <a:extLst>
               <a:ext uri="{FF2B5EF4-FFF2-40B4-BE49-F238E27FC236}">
-                <a16:creationId xmlns:a16="http://schemas.microsoft.com/office/drawing/2014/main" id="{5994D280-E776-FE22-566C-B4458CA4874A}"/>
+                <a16:creationId xmlns:a16="http://schemas.microsoft.com/office/drawing/2014/main" id="{F87A0FD6-24E4-6BDA-AE6E-1D131F44F775}"/>
               </a:ext>
             </a:extLst>
           </p:cNvPr>
@@ -17729,7 +15906,7 @@
         </p:nvSpPr>
         <p:spPr>
           <a:xfrm>
-            <a:off x="5963495" y="5264597"/>
+            <a:off x="5963495" y="6070932"/>
             <a:ext cx="2346275" cy="461665"/>
           </a:xfrm>
           <a:prstGeom prst="rect">
@@ -17770,10 +15947,318 @@
           </a:p>
         </p:txBody>
       </p:sp>
+      <p:sp>
+        <p:nvSpPr>
+          <p:cNvPr id="5" name="テキスト ボックス 4">
+            <a:extLst>
+              <a:ext uri="{FF2B5EF4-FFF2-40B4-BE49-F238E27FC236}">
+                <a16:creationId xmlns:a16="http://schemas.microsoft.com/office/drawing/2014/main" id="{9B2BF6D6-646A-67EA-AB45-9A685D0AE9ED}"/>
+              </a:ext>
+            </a:extLst>
+          </p:cNvPr>
+          <p:cNvSpPr txBox="1"/>
+          <p:nvPr/>
+        </p:nvSpPr>
+        <p:spPr>
+          <a:xfrm>
+            <a:off x="3979379" y="3750316"/>
+            <a:ext cx="2346275" cy="276999"/>
+          </a:xfrm>
+          <a:prstGeom prst="rect">
+            <a:avLst/>
+          </a:prstGeom>
+          <a:noFill/>
+        </p:spPr>
+        <p:txBody>
+          <a:bodyPr wrap="square" rtlCol="0">
+            <a:spAutoFit/>
+          </a:bodyPr>
+          <a:lstStyle/>
+          <a:p>
+            <a:r>
+              <a:rPr kumimoji="1" lang="en-US" altLang="ja-JP" sz="1200" dirty="0"/>
+              <a:t>abc123</a:t>
+            </a:r>
+            <a:r>
+              <a:rPr lang="ja-JP" altLang="en-US" sz="1200" dirty="0"/>
+              <a:t>を</a:t>
+            </a:r>
+            <a:r>
+              <a:rPr lang="en-US" altLang="ja-JP" sz="1200" dirty="0" err="1"/>
+              <a:t>session_id</a:t>
+            </a:r>
+            <a:r>
+              <a:rPr lang="ja-JP" altLang="en-US" sz="1200" dirty="0"/>
+              <a:t>として検索</a:t>
+            </a:r>
+            <a:endParaRPr kumimoji="1" lang="ja-JP" altLang="en-US" sz="1200" dirty="0"/>
+          </a:p>
+        </p:txBody>
+      </p:sp>
+      <p:sp>
+        <p:nvSpPr>
+          <p:cNvPr id="15" name="フローチャート: 処理 14">
+            <a:extLst>
+              <a:ext uri="{FF2B5EF4-FFF2-40B4-BE49-F238E27FC236}">
+                <a16:creationId xmlns:a16="http://schemas.microsoft.com/office/drawing/2014/main" id="{24C863A8-358D-F219-2FD8-4EB4FCD111FD}"/>
+              </a:ext>
+            </a:extLst>
+          </p:cNvPr>
+          <p:cNvSpPr/>
+          <p:nvPr/>
+        </p:nvSpPr>
+        <p:spPr>
+          <a:xfrm>
+            <a:off x="4421458" y="4358447"/>
+            <a:ext cx="1920240" cy="814646"/>
+          </a:xfrm>
+          <a:prstGeom prst="flowChartProcess">
+            <a:avLst/>
+          </a:prstGeom>
+          <a:ln>
+            <a:noFill/>
+          </a:ln>
+        </p:spPr>
+        <p:style>
+          <a:lnRef idx="2">
+            <a:schemeClr val="accent1">
+              <a:shade val="15000"/>
+            </a:schemeClr>
+          </a:lnRef>
+          <a:fillRef idx="1">
+            <a:schemeClr val="accent1"/>
+          </a:fillRef>
+          <a:effectRef idx="0">
+            <a:schemeClr val="accent1"/>
+          </a:effectRef>
+          <a:fontRef idx="minor">
+            <a:schemeClr val="lt1"/>
+          </a:fontRef>
+        </p:style>
+        <p:txBody>
+          <a:bodyPr rtlCol="0" anchor="ctr"/>
+          <a:lstStyle/>
+          <a:p>
+            <a:pPr algn="ctr"/>
+            <a:r>
+              <a:rPr kumimoji="1" lang="ja-JP" altLang="en-US" dirty="0">
+                <a:solidFill>
+                  <a:schemeClr val="tx1">
+                    <a:lumMod val="75000"/>
+                  </a:schemeClr>
+                </a:solidFill>
+              </a:rPr>
+              <a:t>サーバ</a:t>
+            </a:r>
+            <a:r>
+              <a:rPr lang="en-US" altLang="ja-JP" dirty="0">
+                <a:solidFill>
+                  <a:schemeClr val="tx1">
+                    <a:lumMod val="75000"/>
+                  </a:schemeClr>
+                </a:solidFill>
+              </a:rPr>
+              <a:t>B</a:t>
+            </a:r>
+            <a:endParaRPr kumimoji="1" lang="en-US" altLang="ja-JP" dirty="0">
+              <a:solidFill>
+                <a:schemeClr val="tx1">
+                  <a:lumMod val="75000"/>
+                </a:schemeClr>
+              </a:solidFill>
+            </a:endParaRPr>
+          </a:p>
+        </p:txBody>
+      </p:sp>
+      <p:cxnSp>
+        <p:nvCxnSpPr>
+          <p:cNvPr id="25" name="直線矢印コネクタ 24">
+            <a:extLst>
+              <a:ext uri="{FF2B5EF4-FFF2-40B4-BE49-F238E27FC236}">
+                <a16:creationId xmlns:a16="http://schemas.microsoft.com/office/drawing/2014/main" id="{AAFC654C-13A2-0A16-E9E9-C04FE7CDA543}"/>
+              </a:ext>
+            </a:extLst>
+          </p:cNvPr>
+          <p:cNvCxnSpPr>
+            <a:cxnSpLocks/>
+            <a:endCxn id="7" idx="1"/>
+          </p:cNvCxnSpPr>
+          <p:nvPr/>
+        </p:nvCxnSpPr>
+        <p:spPr>
+          <a:xfrm flipV="1">
+            <a:off x="1299094" y="2879724"/>
+            <a:ext cx="3122364" cy="1052627"/>
+          </a:xfrm>
+          <a:prstGeom prst="straightConnector1">
+            <a:avLst/>
+          </a:prstGeom>
+          <a:ln w="44450">
+            <a:tailEnd type="triangle"/>
+          </a:ln>
+        </p:spPr>
+        <p:style>
+          <a:lnRef idx="2">
+            <a:schemeClr val="accent1"/>
+          </a:lnRef>
+          <a:fillRef idx="0">
+            <a:schemeClr val="accent1"/>
+          </a:fillRef>
+          <a:effectRef idx="1">
+            <a:schemeClr val="accent1"/>
+          </a:effectRef>
+          <a:fontRef idx="minor">
+            <a:schemeClr val="tx1"/>
+          </a:fontRef>
+        </p:style>
+      </p:cxnSp>
+      <p:sp>
+        <p:nvSpPr>
+          <p:cNvPr id="14" name="テキスト ボックス 13">
+            <a:extLst>
+              <a:ext uri="{FF2B5EF4-FFF2-40B4-BE49-F238E27FC236}">
+                <a16:creationId xmlns:a16="http://schemas.microsoft.com/office/drawing/2014/main" id="{EE1A979A-D9EF-1A6C-DE3E-34856F25B295}"/>
+              </a:ext>
+            </a:extLst>
+          </p:cNvPr>
+          <p:cNvSpPr txBox="1"/>
+          <p:nvPr/>
+        </p:nvSpPr>
+        <p:spPr>
+          <a:xfrm>
+            <a:off x="1323255" y="3326472"/>
+            <a:ext cx="2191687" cy="830997"/>
+          </a:xfrm>
+          <a:prstGeom prst="rect">
+            <a:avLst/>
+          </a:prstGeom>
+          <a:noFill/>
+        </p:spPr>
+        <p:txBody>
+          <a:bodyPr wrap="square" rtlCol="0">
+            <a:spAutoFit/>
+          </a:bodyPr>
+          <a:lstStyle/>
+          <a:p>
+            <a:r>
+              <a:rPr kumimoji="1" lang="en-US" altLang="ja-JP" sz="1200" dirty="0"/>
+              <a:t>GET /</a:t>
+            </a:r>
+            <a:r>
+              <a:rPr kumimoji="1" lang="en-US" altLang="ja-JP" sz="1200" dirty="0" err="1"/>
+              <a:t>mypage</a:t>
+            </a:r>
+            <a:endParaRPr kumimoji="1" lang="en-US" altLang="ja-JP" sz="1200" dirty="0"/>
+          </a:p>
+          <a:p>
+            <a:r>
+              <a:rPr lang="en-US" altLang="ja-JP" sz="1200" b="1" dirty="0"/>
+              <a:t>Cookie:</a:t>
+            </a:r>
+          </a:p>
+          <a:p>
+            <a:r>
+              <a:rPr kumimoji="1" lang="en-US" altLang="ja-JP" sz="1200" b="1" dirty="0" err="1"/>
+              <a:t>Session_id</a:t>
+            </a:r>
+            <a:r>
+              <a:rPr kumimoji="1" lang="en-US" altLang="ja-JP" sz="1200" b="1" dirty="0"/>
+              <a:t>=abc123</a:t>
+            </a:r>
+          </a:p>
+          <a:p>
+            <a:endParaRPr kumimoji="1" lang="ja-JP" altLang="en-US" sz="1200" dirty="0"/>
+          </a:p>
+        </p:txBody>
+      </p:sp>
+      <p:cxnSp>
+        <p:nvCxnSpPr>
+          <p:cNvPr id="28" name="直線矢印コネクタ 27">
+            <a:extLst>
+              <a:ext uri="{FF2B5EF4-FFF2-40B4-BE49-F238E27FC236}">
+                <a16:creationId xmlns:a16="http://schemas.microsoft.com/office/drawing/2014/main" id="{CEA932BB-52DE-3AD7-5D56-283FF5BCC42F}"/>
+              </a:ext>
+            </a:extLst>
+          </p:cNvPr>
+          <p:cNvCxnSpPr>
+            <a:cxnSpLocks/>
+            <a:stCxn id="15" idx="3"/>
+          </p:cNvCxnSpPr>
+          <p:nvPr/>
+        </p:nvCxnSpPr>
+        <p:spPr>
+          <a:xfrm flipV="1">
+            <a:off x="6341698" y="4292288"/>
+            <a:ext cx="1920240" cy="473482"/>
+          </a:xfrm>
+          <a:prstGeom prst="straightConnector1">
+            <a:avLst/>
+          </a:prstGeom>
+          <a:ln w="44450">
+            <a:tailEnd type="triangle"/>
+          </a:ln>
+        </p:spPr>
+        <p:style>
+          <a:lnRef idx="2">
+            <a:schemeClr val="accent1"/>
+          </a:lnRef>
+          <a:fillRef idx="0">
+            <a:schemeClr val="accent1"/>
+          </a:fillRef>
+          <a:effectRef idx="1">
+            <a:schemeClr val="accent1"/>
+          </a:effectRef>
+          <a:fontRef idx="minor">
+            <a:schemeClr val="tx1"/>
+          </a:fontRef>
+        </p:style>
+      </p:cxnSp>
+      <p:cxnSp>
+        <p:nvCxnSpPr>
+          <p:cNvPr id="31" name="直線矢印コネクタ 30">
+            <a:extLst>
+              <a:ext uri="{FF2B5EF4-FFF2-40B4-BE49-F238E27FC236}">
+                <a16:creationId xmlns:a16="http://schemas.microsoft.com/office/drawing/2014/main" id="{ED0E1DF1-94B6-4E48-6D5A-95A613F74768}"/>
+              </a:ext>
+            </a:extLst>
+          </p:cNvPr>
+          <p:cNvCxnSpPr>
+            <a:cxnSpLocks/>
+            <a:stCxn id="7" idx="3"/>
+          </p:cNvCxnSpPr>
+          <p:nvPr/>
+        </p:nvCxnSpPr>
+        <p:spPr>
+          <a:xfrm>
+            <a:off x="6341698" y="2879724"/>
+            <a:ext cx="1920240" cy="1260541"/>
+          </a:xfrm>
+          <a:prstGeom prst="straightConnector1">
+            <a:avLst/>
+          </a:prstGeom>
+          <a:ln w="44450">
+            <a:tailEnd type="triangle"/>
+          </a:ln>
+        </p:spPr>
+        <p:style>
+          <a:lnRef idx="2">
+            <a:schemeClr val="accent1"/>
+          </a:lnRef>
+          <a:fillRef idx="0">
+            <a:schemeClr val="accent1"/>
+          </a:fillRef>
+          <a:effectRef idx="1">
+            <a:schemeClr val="accent1"/>
+          </a:effectRef>
+          <a:fontRef idx="minor">
+            <a:schemeClr val="tx1"/>
+          </a:fontRef>
+        </p:style>
+      </p:cxnSp>
     </p:spTree>
     <p:extLst>
       <p:ext uri="{BB962C8B-B14F-4D97-AF65-F5344CB8AC3E}">
-        <p14:creationId xmlns:p14="http://schemas.microsoft.com/office/powerpoint/2010/main" val="1749543985"/>
+        <p14:creationId xmlns:p14="http://schemas.microsoft.com/office/powerpoint/2010/main" val="3014831916"/>
       </p:ext>
     </p:extLst>
   </p:cSld>

</xml_diff>